<commit_message>
feat: synchronisation globale certif CDSD Blocs 1 a 6 (notebooks, supports PPTX, READMEs, visuels et guides API)
</commit_message>
<xml_diff>
--- a/Bloc_3_Machine_Learning/Conversion_Rate/Conversion_rate_presentation.pptx
+++ b/Bloc_3_Machine_Learning/Conversion_Rate/Conversion_rate_presentation.pptx
@@ -2,49 +2,49 @@
 <file path=ppt/presentation.xml><?xml version="1.0" encoding="utf-8"?>
 <p:presentation xmlns:a="http://schemas.openxmlformats.org/drawingml/2006/main" xmlns:r="http://schemas.openxmlformats.org/officeDocument/2006/relationships" xmlns:mc="http://schemas.openxmlformats.org/markup-compatibility/2006" xmlns:mv="urn:schemas-microsoft-com:mac:vml" xmlns:p="http://schemas.openxmlformats.org/presentationml/2006/main" xmlns:c="http://schemas.openxmlformats.org/drawingml/2006/chart" xmlns:dgm="http://schemas.openxmlformats.org/drawingml/2006/diagram" xmlns:o="urn:schemas-microsoft-com:office:office" xmlns:v="urn:schemas-microsoft-com:vml" xmlns:pvml="urn:schemas-microsoft-com:office:powerpoint" xmlns:com="http://schemas.openxmlformats.org/drawingml/2006/compatibility" xmlns:p14="http://schemas.microsoft.com/office/powerpoint/2010/main" xmlns:p15="http://schemas.microsoft.com/office/powerpoint/2012/main" xmlns:ahyp="http://schemas.microsoft.com/office/drawing/2018/hyperlinkcolor" autoCompressPictures="0" embedTrueTypeFonts="1" strictFirstAndLastChars="0" saveSubsetFonts="1">
   <p:sldMasterIdLst>
-    <p:sldMasterId id="2147483648" r:id="rId5"/>
+    <p:sldMasterId id="2147483648" r:id="rId4"/>
   </p:sldMasterIdLst>
   <p:notesMasterIdLst>
-    <p:notesMasterId r:id="rId6"/>
+    <p:notesMasterId r:id="rId5"/>
   </p:notesMasterIdLst>
   <p:sldIdLst>
-    <p:sldId id="256" r:id="rId7"/>
-    <p:sldId id="257" r:id="rId8"/>
-    <p:sldId id="258" r:id="rId9"/>
-    <p:sldId id="259" r:id="rId10"/>
-    <p:sldId id="260" r:id="rId11"/>
-    <p:sldId id="261" r:id="rId12"/>
-    <p:sldId id="262" r:id="rId13"/>
-    <p:sldId id="263" r:id="rId14"/>
+    <p:sldId id="256" r:id="rId6"/>
+    <p:sldId id="257" r:id="rId7"/>
+    <p:sldId id="258" r:id="rId8"/>
+    <p:sldId id="259" r:id="rId9"/>
+    <p:sldId id="260" r:id="rId10"/>
+    <p:sldId id="261" r:id="rId11"/>
+    <p:sldId id="262" r:id="rId12"/>
+    <p:sldId id="263" r:id="rId13"/>
   </p:sldIdLst>
   <p:sldSz cy="6858000" cx="12191675"/>
   <p:notesSz cx="6858000" cy="9144000"/>
   <p:embeddedFontLst>
     <p:embeddedFont>
       <p:font typeface="Inter SemiBold"/>
-      <p:regular r:id="rId15"/>
-      <p:bold r:id="rId16"/>
-      <p:italic r:id="rId17"/>
-      <p:boldItalic r:id="rId18"/>
+      <p:regular r:id="rId14"/>
+      <p:bold r:id="rId15"/>
+      <p:italic r:id="rId16"/>
+      <p:boldItalic r:id="rId17"/>
     </p:embeddedFont>
     <p:embeddedFont>
       <p:font typeface="Inter"/>
-      <p:regular r:id="rId19"/>
-      <p:bold r:id="rId20"/>
-      <p:italic r:id="rId21"/>
-      <p:boldItalic r:id="rId22"/>
+      <p:regular r:id="rId18"/>
+      <p:bold r:id="rId19"/>
+      <p:italic r:id="rId20"/>
+      <p:boldItalic r:id="rId21"/>
     </p:embeddedFont>
     <p:embeddedFont>
       <p:font typeface="Inter ExtraBold"/>
-      <p:bold r:id="rId23"/>
-      <p:boldItalic r:id="rId24"/>
+      <p:bold r:id="rId22"/>
+      <p:boldItalic r:id="rId23"/>
     </p:embeddedFont>
     <p:embeddedFont>
       <p:font typeface="Inter Medium"/>
-      <p:regular r:id="rId25"/>
-      <p:bold r:id="rId26"/>
-      <p:italic r:id="rId27"/>
-      <p:boldItalic r:id="rId28"/>
+      <p:regular r:id="rId24"/>
+      <p:bold r:id="rId25"/>
+      <p:italic r:id="rId26"/>
+      <p:boldItalic r:id="rId27"/>
     </p:embeddedFont>
   </p:embeddedFontLst>
   <p:defaultTextStyle>
@@ -292,7 +292,7 @@
       </p15:sldGuideLst>
     </p:ext>
     <p:ext uri="GoogleSlidesCustomDataVersion2">
-      <go:slidesCustomData xmlns:go="http://customooxmlschemas.google.com/" r:id="rId29" roundtripDataSignature="AMtx7mjIVTh6aeTglY0SduX9jd7eHytVuw=="/>
+      <go:slidesCustomData xmlns:go="http://customooxmlschemas.google.com/" r:id="rId28" roundtripDataSignature="AMtx7mhS4pq3C0AHajIwKW3GlxC9a90Vhg=="/>
     </p:ext>
   </p:extLst>
 </p:presentation>
@@ -1683,7 +1683,7 @@
   <p:cSld>
     <p:spTree>
       <p:nvGrpSpPr>
-        <p:cNvPr id="189" name="Shape 189"/>
+        <p:cNvPr id="186" name="Shape 186"/>
         <p:cNvGrpSpPr/>
         <p:nvPr/>
       </p:nvGrpSpPr>
@@ -1697,7 +1697,7 @@
       </p:grpSpPr>
       <p:sp>
         <p:nvSpPr>
-          <p:cNvPr id="190" name="Google Shape;190;p8:notes"/>
+          <p:cNvPr id="187" name="Google Shape;187;p8:notes"/>
           <p:cNvSpPr txBox="1"/>
           <p:nvPr>
             <p:ph idx="1" type="body"/>
@@ -1744,7 +1744,7 @@
       </p:sp>
       <p:sp>
         <p:nvSpPr>
-          <p:cNvPr id="191" name="Google Shape;191;p8:notes"/>
+          <p:cNvPr id="188" name="Google Shape;188;p8:notes"/>
           <p:cNvSpPr/>
           <p:nvPr>
             <p:ph idx="2" type="sldImg"/>
@@ -14961,7 +14961,7 @@
               <a:buNone/>
             </a:pPr>
             <a:r>
-              <a:rPr b="1" i="0" lang="en-US" sz="1100" u="none" cap="none" strike="noStrike">
+              <a:rPr b="1" i="0" lang="en-US" sz="1500" u="none" cap="none" strike="noStrike">
                 <a:solidFill>
                   <a:srgbClr val="38BDF8"/>
                 </a:solidFill>
@@ -14972,7 +14972,7 @@
               </a:rPr>
               <a:t>CHALLENGE MACHINE LEARNING SUPERVISÉ • CLASSIFICATION &amp; BUSINESS INSIGHTS</a:t>
             </a:r>
-            <a:endParaRPr b="1" i="0" sz="1100" u="none" cap="none" strike="noStrike">
+            <a:endParaRPr b="1" i="0" sz="1500" u="none" cap="none" strike="noStrike">
               <a:solidFill>
                 <a:srgbClr val="38BDF8"/>
               </a:solidFill>
@@ -15313,6 +15313,34 @@
                 </a:rPr>
                 <a:t>284 580</a:t>
               </a:r>
+              <a:endParaRPr b="0" i="0" sz="3600" u="none" cap="none" strike="noStrike">
+                <a:solidFill>
+                  <a:srgbClr val="FFFFFF"/>
+                </a:solidFill>
+                <a:latin typeface="Inter ExtraBold"/>
+                <a:ea typeface="Inter ExtraBold"/>
+                <a:cs typeface="Inter ExtraBold"/>
+                <a:sym typeface="Inter ExtraBold"/>
+              </a:endParaRPr>
+            </a:p>
+            <a:p>
+              <a:pPr indent="0" lvl="0" marL="0" marR="0" rtl="0" algn="l">
+                <a:lnSpc>
+                  <a:spcPct val="100000"/>
+                </a:lnSpc>
+                <a:spcBef>
+                  <a:spcPts val="0"/>
+                </a:spcBef>
+                <a:spcAft>
+                  <a:spcPts val="0"/>
+                </a:spcAft>
+                <a:buClr>
+                  <a:srgbClr val="000000"/>
+                </a:buClr>
+                <a:buSzPts val="3600"/>
+                <a:buFont typeface="Arial"/>
+                <a:buNone/>
+              </a:pPr>
               <a:r>
                 <a:rPr b="0" i="0" lang="en-US" sz="1200" u="none" cap="none" strike="noStrike">
                   <a:solidFill>
@@ -15534,6 +15562,34 @@
                 </a:rPr>
                 <a:t>3,23 %</a:t>
               </a:r>
+              <a:endParaRPr b="0" i="0" sz="3600" u="none" cap="none" strike="noStrike">
+                <a:solidFill>
+                  <a:srgbClr val="FFFFFF"/>
+                </a:solidFill>
+                <a:latin typeface="Inter ExtraBold"/>
+                <a:ea typeface="Inter ExtraBold"/>
+                <a:cs typeface="Inter ExtraBold"/>
+                <a:sym typeface="Inter ExtraBold"/>
+              </a:endParaRPr>
+            </a:p>
+            <a:p>
+              <a:pPr indent="0" lvl="0" marL="0" marR="0" rtl="0" algn="l">
+                <a:lnSpc>
+                  <a:spcPct val="100000"/>
+                </a:lnSpc>
+                <a:spcBef>
+                  <a:spcPts val="0"/>
+                </a:spcBef>
+                <a:spcAft>
+                  <a:spcPts val="0"/>
+                </a:spcAft>
+                <a:buClr>
+                  <a:srgbClr val="000000"/>
+                </a:buClr>
+                <a:buSzPts val="3600"/>
+                <a:buFont typeface="Arial"/>
+                <a:buNone/>
+              </a:pPr>
               <a:r>
                 <a:rPr b="0" i="0" lang="en-US" sz="1200" u="none" cap="none" strike="noStrike">
                   <a:solidFill>
@@ -15568,7 +15624,7 @@
         <p:grpSpPr>
           <a:xfrm>
             <a:off x="8001000" y="3429000"/>
-            <a:ext cx="3238500" cy="1714500"/>
+            <a:ext cx="3595383" cy="1714500"/>
             <a:chOff x="0" y="0"/>
             <a:chExt cx="3238500" cy="1714500"/>
           </a:xfrm>
@@ -15709,8 +15765,8 @@
           </p:nvSpPr>
           <p:spPr>
             <a:xfrm>
-              <a:off x="228600" y="285750"/>
-              <a:ext cx="2781300" cy="1143000"/>
+              <a:off x="228607" y="285750"/>
+              <a:ext cx="2764800" cy="1143000"/>
             </a:xfrm>
             <a:prstGeom prst="rect">
               <a:avLst/>
@@ -15753,8 +15809,36 @@
                   <a:cs typeface="Inter ExtraBold"/>
                   <a:sym typeface="Inter ExtraBold"/>
                 </a:rPr>
-                <a:t>F1 = 0,7762</a:t>
+                <a:t>F1 = 0,7772</a:t>
               </a:r>
+              <a:endParaRPr b="0" i="0" sz="3200" u="none" cap="none" strike="noStrike">
+                <a:solidFill>
+                  <a:srgbClr val="FFFFFF"/>
+                </a:solidFill>
+                <a:latin typeface="Inter ExtraBold"/>
+                <a:ea typeface="Inter ExtraBold"/>
+                <a:cs typeface="Inter ExtraBold"/>
+                <a:sym typeface="Inter ExtraBold"/>
+              </a:endParaRPr>
+            </a:p>
+            <a:p>
+              <a:pPr indent="0" lvl="0" marL="0" marR="0" rtl="0" algn="l">
+                <a:lnSpc>
+                  <a:spcPct val="100000"/>
+                </a:lnSpc>
+                <a:spcBef>
+                  <a:spcPts val="0"/>
+                </a:spcBef>
+                <a:spcAft>
+                  <a:spcPts val="0"/>
+                </a:spcAft>
+                <a:buClr>
+                  <a:srgbClr val="000000"/>
+                </a:buClr>
+                <a:buSzPts val="3200"/>
+                <a:buFont typeface="Arial"/>
+                <a:buNone/>
+              </a:pPr>
               <a:r>
                 <a:rPr b="0" i="0" lang="en-US" sz="1200" u="none" cap="none" strike="noStrike">
                   <a:solidFill>
@@ -15823,7 +15907,7 @@
               <a:buNone/>
             </a:pPr>
             <a:r>
-              <a:rPr b="0" i="0" lang="en-US" sz="1200" u="none" cap="none" strike="noStrike">
+              <a:rPr b="1" i="0" lang="en-US" sz="1200" u="none" cap="none" strike="noStrike">
                 <a:solidFill>
                   <a:srgbClr val="FFFFFF"/>
                 </a:solidFill>
@@ -15832,7 +15916,7 @@
                 <a:cs typeface="Inter SemiBold"/>
                 <a:sym typeface="Inter SemiBold"/>
               </a:rPr>
-              <a:t>Christopher Gilleron</a:t>
+              <a:t>Christopher Gilleron			 </a:t>
             </a:r>
             <a:r>
               <a:rPr b="0" i="0" lang="en-US" sz="1050" u="none" cap="none" strike="noStrike">
@@ -15844,10 +15928,10 @@
                 <a:cs typeface="Inter"/>
                 <a:sym typeface="Inter"/>
               </a:rPr>
-              <a:t>8 octobre 2026</a:t>
+              <a:t>8 octobre 2026			</a:t>
             </a:r>
             <a:r>
-              <a:rPr b="0" i="0" lang="en-US" sz="1050" u="none" cap="none" strike="noStrike">
+              <a:rPr b="1" i="0" lang="en-US" sz="1050" u="none" cap="none" strike="noStrike">
                 <a:solidFill>
                   <a:srgbClr val="3FDAD2"/>
                 </a:solidFill>
@@ -15904,7 +15988,7 @@
         <p:spPr>
           <a:xfrm>
             <a:off x="731520" y="411480"/>
-            <a:ext cx="10698480" cy="320040"/>
+            <a:ext cx="10698600" cy="261600"/>
           </a:xfrm>
           <a:prstGeom prst="rect">
             <a:avLst/>
@@ -15938,7 +16022,7 @@
               <a:buNone/>
             </a:pPr>
             <a:r>
-              <a:rPr b="1" i="0" lang="en-US" sz="1000" u="none" cap="none" strike="noStrike">
+              <a:rPr b="1" i="0" lang="en-US" sz="1700" u="none" cap="none" strike="noStrike">
                 <a:solidFill>
                   <a:srgbClr val="2563EB"/>
                 </a:solidFill>
@@ -15949,7 +16033,7 @@
               </a:rPr>
               <a:t>ÉTAPE 01  |  CADRAGE DU PROJET</a:t>
             </a:r>
-            <a:endParaRPr b="0" i="0" sz="1400" u="none" cap="none" strike="noStrike">
+            <a:endParaRPr b="0" i="0" sz="2100" u="none" cap="none" strike="noStrike">
               <a:solidFill>
                 <a:srgbClr val="000000"/>
               </a:solidFill>
@@ -17157,7 +17241,7 @@
         <p:spPr>
           <a:xfrm>
             <a:off x="731520" y="411480"/>
-            <a:ext cx="10698480" cy="320040"/>
+            <a:ext cx="10698600" cy="277200"/>
           </a:xfrm>
           <a:prstGeom prst="rect">
             <a:avLst/>
@@ -17191,7 +17275,7 @@
               <a:buNone/>
             </a:pPr>
             <a:r>
-              <a:rPr b="1" i="0" lang="en-US" sz="1000" u="none" cap="none" strike="noStrike">
+              <a:rPr b="1" i="0" lang="en-US" sz="1800" u="none" cap="none" strike="noStrike">
                 <a:solidFill>
                   <a:srgbClr val="2563EB"/>
                 </a:solidFill>
@@ -17202,7 +17286,7 @@
               </a:rPr>
               <a:t>ÉTAPE 02  |  EXPLORATION DES DONNÉES</a:t>
             </a:r>
-            <a:endParaRPr b="0" i="0" sz="1400" u="none" cap="none" strike="noStrike">
+            <a:endParaRPr b="0" i="0" sz="2200" u="none" cap="none" strike="noStrike">
               <a:solidFill>
                 <a:srgbClr val="000000"/>
               </a:solidFill>
@@ -17832,7 +17916,7 @@
         <p:spPr>
           <a:xfrm>
             <a:off x="731520" y="411480"/>
-            <a:ext cx="10698480" cy="320040"/>
+            <a:ext cx="10698600" cy="292500"/>
           </a:xfrm>
           <a:prstGeom prst="rect">
             <a:avLst/>
@@ -17866,7 +17950,7 @@
               <a:buNone/>
             </a:pPr>
             <a:r>
-              <a:rPr b="1" i="0" lang="en-US" sz="1000" u="none" cap="none" strike="noStrike">
+              <a:rPr b="1" i="0" lang="en-US" sz="1900" u="none" cap="none" strike="noStrike">
                 <a:solidFill>
                   <a:srgbClr val="2563EB"/>
                 </a:solidFill>
@@ -17877,7 +17961,7 @@
               </a:rPr>
               <a:t>ÉTAPE 03  |  COMPORTEMENT UTILISATEUR</a:t>
             </a:r>
-            <a:endParaRPr b="0" i="0" sz="1400" u="none" cap="none" strike="noStrike">
+            <a:endParaRPr b="0" i="0" sz="2300" u="none" cap="none" strike="noStrike">
               <a:solidFill>
                 <a:srgbClr val="000000"/>
               </a:solidFill>
@@ -17964,7 +18048,7 @@
         <p:spPr>
           <a:xfrm>
             <a:off x="731520" y="1234440"/>
-            <a:ext cx="10698480" cy="320040"/>
+            <a:ext cx="10698600" cy="323100"/>
           </a:xfrm>
           <a:prstGeom prst="rect">
             <a:avLst/>
@@ -17998,7 +18082,7 @@
               <a:buNone/>
             </a:pPr>
             <a:r>
-              <a:rPr b="0" i="0" lang="en-US" sz="1200" u="none" cap="none" strike="noStrike">
+              <a:rPr b="0" i="0" lang="en-US" sz="2100" u="none" cap="none" strike="noStrike">
                 <a:solidFill>
                   <a:srgbClr val="64748B"/>
                 </a:solidFill>
@@ -18009,7 +18093,7 @@
               </a:rPr>
               <a:t>Le nombre de pages vues sépare quasi-parfaitement les deux populations</a:t>
             </a:r>
-            <a:endParaRPr b="0" i="0" sz="1400" u="none" cap="none" strike="noStrike">
+            <a:endParaRPr b="0" i="0" sz="2300" u="none" cap="none" strike="noStrike">
               <a:solidFill>
                 <a:srgbClr val="000000"/>
               </a:solidFill>
@@ -18519,13 +18603,17 @@
         </p:nvSpPr>
         <p:spPr>
           <a:xfrm>
-            <a:off x="731520" y="411480"/>
-            <a:ext cx="10698600" cy="153900"/>
+            <a:off x="731520" y="381000"/>
+            <a:ext cx="10698600" cy="261600"/>
           </a:xfrm>
           <a:prstGeom prst="rect">
             <a:avLst/>
           </a:prstGeom>
-          <a:noFill/>
+          <a:solidFill>
+            <a:srgbClr val="000000">
+              <a:alpha val="0"/>
+            </a:srgbClr>
+          </a:solidFill>
           <a:ln>
             <a:noFill/>
           </a:ln>
@@ -18536,43 +18624,35 @@
           </a:bodyPr>
           <a:lstStyle/>
           <a:p>
-            <a:pPr indent="0" lvl="0" marL="0" marR="0" rtl="0" algn="l">
-              <a:lnSpc>
-                <a:spcPct val="100000"/>
-              </a:lnSpc>
-              <a:spcBef>
-                <a:spcPts val="0"/>
-              </a:spcBef>
-              <a:spcAft>
-                <a:spcPts val="0"/>
-              </a:spcAft>
-              <a:buClr>
-                <a:srgbClr val="000000"/>
-              </a:buClr>
-              <a:buSzPts val="1000"/>
-              <a:buFont typeface="Arial"/>
+            <a:pPr indent="0" lvl="0" marL="0" rtl="0" algn="l">
+              <a:spcBef>
+                <a:spcPts val="0"/>
+              </a:spcBef>
+              <a:spcAft>
+                <a:spcPts val="0"/>
+              </a:spcAft>
               <a:buNone/>
             </a:pPr>
             <a:r>
-              <a:rPr b="1" i="0" lang="en-US" sz="1000" u="none" cap="none" strike="noStrike">
+              <a:rPr b="1" lang="en-US" sz="1700">
                 <a:solidFill>
                   <a:srgbClr val="2563EB"/>
                 </a:solidFill>
-                <a:latin typeface="Calibri"/>
-                <a:ea typeface="Calibri"/>
-                <a:cs typeface="Calibri"/>
-                <a:sym typeface="Calibri"/>
+                <a:latin typeface="Inter"/>
+                <a:ea typeface="Inter"/>
+                <a:cs typeface="Inter"/>
+                <a:sym typeface="Inter"/>
               </a:rPr>
-              <a:t>ÉTAPE 04  |  PIPELINE DE MODÉLISATION</a:t>
+              <a:t>ÉTAPE 04 | PIPELINE DE MODÉLISATION</a:t>
             </a:r>
-            <a:endParaRPr b="0" i="0" sz="1400" u="none" cap="none" strike="noStrike">
+            <a:endParaRPr b="1" sz="1700">
               <a:solidFill>
-                <a:srgbClr val="000000"/>
+                <a:srgbClr val="2563EB"/>
               </a:solidFill>
-              <a:latin typeface="Arial"/>
-              <a:ea typeface="Arial"/>
-              <a:cs typeface="Arial"/>
-              <a:sym typeface="Arial"/>
+              <a:latin typeface="Inter"/>
+              <a:ea typeface="Inter"/>
+              <a:cs typeface="Inter"/>
+              <a:sym typeface="Inter"/>
             </a:endParaRPr>
           </a:p>
         </p:txBody>
@@ -18585,13 +18665,17 @@
         </p:nvSpPr>
         <p:spPr>
           <a:xfrm>
-            <a:off x="731520" y="685800"/>
-            <a:ext cx="10698600" cy="338700"/>
+            <a:off x="731520" y="647700"/>
+            <a:ext cx="10698600" cy="384900"/>
           </a:xfrm>
           <a:prstGeom prst="rect">
             <a:avLst/>
           </a:prstGeom>
-          <a:noFill/>
+          <a:solidFill>
+            <a:srgbClr val="000000">
+              <a:alpha val="0"/>
+            </a:srgbClr>
+          </a:solidFill>
           <a:ln>
             <a:noFill/>
           </a:ln>
@@ -18602,43 +18686,35 @@
           </a:bodyPr>
           <a:lstStyle/>
           <a:p>
-            <a:pPr indent="0" lvl="0" marL="0" marR="0" rtl="0" algn="l">
-              <a:lnSpc>
-                <a:spcPct val="100000"/>
-              </a:lnSpc>
-              <a:spcBef>
-                <a:spcPts val="0"/>
-              </a:spcBef>
-              <a:spcAft>
-                <a:spcPts val="0"/>
-              </a:spcAft>
-              <a:buClr>
-                <a:srgbClr val="000000"/>
-              </a:buClr>
-              <a:buSzPts val="2200"/>
-              <a:buFont typeface="Arial"/>
+            <a:pPr indent="0" lvl="0" marL="0" rtl="0" algn="l">
+              <a:spcBef>
+                <a:spcPts val="0"/>
+              </a:spcBef>
+              <a:spcAft>
+                <a:spcPts val="0"/>
+              </a:spcAft>
               <a:buNone/>
             </a:pPr>
             <a:r>
-              <a:rPr b="1" i="0" lang="en-US" sz="2200" u="none" cap="none" strike="noStrike">
+              <a:rPr b="0" lang="en-US" sz="2500">
                 <a:solidFill>
                   <a:srgbClr val="0F172A"/>
                 </a:solidFill>
-                <a:latin typeface="Calibri"/>
-                <a:ea typeface="Calibri"/>
-                <a:cs typeface="Calibri"/>
-                <a:sym typeface="Calibri"/>
+                <a:latin typeface="Inter ExtraBold"/>
+                <a:ea typeface="Inter ExtraBold"/>
+                <a:cs typeface="Inter ExtraBold"/>
+                <a:sym typeface="Inter ExtraBold"/>
               </a:rPr>
               <a:t>Architecture du Pipeline &amp; Modèle de Référence</a:t>
             </a:r>
-            <a:endParaRPr b="0" i="0" sz="1400" u="none" cap="none" strike="noStrike">
+            <a:endParaRPr b="0" sz="2500">
               <a:solidFill>
-                <a:srgbClr val="000000"/>
+                <a:srgbClr val="0F172A"/>
               </a:solidFill>
-              <a:latin typeface="Arial"/>
-              <a:ea typeface="Arial"/>
-              <a:cs typeface="Arial"/>
-              <a:sym typeface="Arial"/>
+              <a:latin typeface="Inter ExtraBold"/>
+              <a:ea typeface="Inter ExtraBold"/>
+              <a:cs typeface="Inter ExtraBold"/>
+              <a:sym typeface="Inter ExtraBold"/>
             </a:endParaRPr>
           </a:p>
         </p:txBody>
@@ -18651,13 +18727,17 @@
         </p:nvSpPr>
         <p:spPr>
           <a:xfrm>
-            <a:off x="731520" y="1234440"/>
-            <a:ext cx="10698600" cy="184800"/>
+            <a:off x="731520" y="1047750"/>
+            <a:ext cx="10698600" cy="277200"/>
           </a:xfrm>
           <a:prstGeom prst="rect">
             <a:avLst/>
           </a:prstGeom>
-          <a:noFill/>
+          <a:solidFill>
+            <a:srgbClr val="000000">
+              <a:alpha val="0"/>
+            </a:srgbClr>
+          </a:solidFill>
           <a:ln>
             <a:noFill/>
           </a:ln>
@@ -18668,43 +18748,35 @@
           </a:bodyPr>
           <a:lstStyle/>
           <a:p>
-            <a:pPr indent="0" lvl="0" marL="0" marR="0" rtl="0" algn="l">
-              <a:lnSpc>
-                <a:spcPct val="100000"/>
-              </a:lnSpc>
-              <a:spcBef>
-                <a:spcPts val="0"/>
-              </a:spcBef>
-              <a:spcAft>
-                <a:spcPts val="0"/>
-              </a:spcAft>
-              <a:buClr>
-                <a:srgbClr val="000000"/>
-              </a:buClr>
-              <a:buSzPts val="1200"/>
-              <a:buFont typeface="Arial"/>
+            <a:pPr indent="0" lvl="0" marL="0" rtl="0" algn="l">
+              <a:spcBef>
+                <a:spcPts val="0"/>
+              </a:spcBef>
+              <a:spcAft>
+                <a:spcPts val="0"/>
+              </a:spcAft>
               <a:buNone/>
             </a:pPr>
             <a:r>
-              <a:rPr b="0" i="0" lang="en-US" sz="1200" u="none" cap="none" strike="noStrike">
+              <a:rPr b="0" lang="en-US" sz="1800">
                 <a:solidFill>
                   <a:srgbClr val="64748B"/>
                 </a:solidFill>
-                <a:latin typeface="Calibri"/>
-                <a:ea typeface="Calibri"/>
-                <a:cs typeface="Calibri"/>
-                <a:sym typeface="Calibri"/>
+                <a:latin typeface="Inter"/>
+                <a:ea typeface="Inter"/>
+                <a:cs typeface="Inter"/>
+                <a:sym typeface="Inter"/>
               </a:rPr>
               <a:t>Zéro fuite d'information grâce au ColumnTransformer et split stratifié 80/20</a:t>
             </a:r>
-            <a:endParaRPr b="0" i="0" sz="1400" u="none" cap="none" strike="noStrike">
+            <a:endParaRPr b="0" sz="1800">
               <a:solidFill>
-                <a:srgbClr val="000000"/>
+                <a:srgbClr val="64748B"/>
               </a:solidFill>
-              <a:latin typeface="Arial"/>
-              <a:ea typeface="Arial"/>
-              <a:cs typeface="Arial"/>
-              <a:sym typeface="Arial"/>
+              <a:latin typeface="Inter"/>
+              <a:ea typeface="Inter"/>
+              <a:cs typeface="Inter"/>
+              <a:sym typeface="Inter"/>
             </a:endParaRPr>
           </a:p>
         </p:txBody>
@@ -18769,7 +18841,7 @@
             <a:r>
               <a:t/>
             </a:r>
-            <a:endParaRPr b="0" i="0" sz="1800" u="none" cap="none" strike="noStrike">
+            <a:endParaRPr b="0" i="0" sz="2100" u="none" cap="none" strike="noStrike">
               <a:solidFill>
                 <a:schemeClr val="dk1"/>
               </a:solidFill>
@@ -18790,7 +18862,7 @@
         <p:spPr>
           <a:xfrm>
             <a:off x="731520" y="6446520"/>
-            <a:ext cx="10728600" cy="292500"/>
+            <a:ext cx="10728600" cy="384900"/>
           </a:xfrm>
           <a:prstGeom prst="rect">
             <a:avLst/>
@@ -18824,7 +18896,7 @@
               <a:buNone/>
             </a:pPr>
             <a:r>
-              <a:rPr b="0" i="0" lang="en-US" sz="950" u="none" cap="none" strike="noStrike">
+              <a:rPr b="0" i="0" lang="en-US" sz="1250" u="none" cap="none" strike="noStrike">
                 <a:solidFill>
                   <a:srgbClr val="64748B"/>
                 </a:solidFill>
@@ -18835,7 +18907,7 @@
               </a:rPr>
               <a:t>Certification CDSD — Bloc 3 : Machine Learning Supervisé  |  Projet Conversion Rate  |  Chris Gilleron</a:t>
             </a:r>
-            <a:endParaRPr b="0" i="0" sz="1400" u="none" cap="none" strike="noStrike">
+            <a:endParaRPr b="0" i="0" sz="1700" u="none" cap="none" strike="noStrike">
               <a:solidFill>
                 <a:srgbClr val="000000"/>
               </a:solidFill>
@@ -18864,7 +18936,7 @@
               <a:buNone/>
             </a:pPr>
             <a:r>
-              <a:rPr b="1" i="0" lang="en-US" sz="950" u="none" cap="none" strike="noStrike">
+              <a:rPr b="1" i="0" lang="en-US" sz="1250" u="none" cap="none" strike="noStrike">
                 <a:solidFill>
                   <a:srgbClr val="0F172A"/>
                 </a:solidFill>
@@ -18875,7 +18947,7 @@
               </a:rPr>
               <a:t>5 / 8</a:t>
             </a:r>
-            <a:endParaRPr b="0" i="0" sz="1400" u="none" cap="none" strike="noStrike">
+            <a:endParaRPr b="0" i="0" sz="1700" u="none" cap="none" strike="noStrike">
               <a:solidFill>
                 <a:srgbClr val="000000"/>
               </a:solidFill>
@@ -18895,20 +18967,20 @@
         </p:nvSpPr>
         <p:spPr>
           <a:xfrm>
-            <a:off x="731520" y="1645920"/>
-            <a:ext cx="2560200" cy="2011800"/>
+            <a:off x="731520" y="1476375"/>
+            <a:ext cx="2495700" cy="1857300"/>
           </a:xfrm>
           <a:prstGeom prst="roundRect">
             <a:avLst>
-              <a:gd fmla="val 7575" name="adj"/>
+              <a:gd fmla="val 6153" name="adj"/>
             </a:avLst>
           </a:prstGeom>
           <a:solidFill>
-            <a:srgbClr val="FFFFFF"/>
+            <a:srgbClr val="F8FAFC"/>
           </a:solidFill>
           <a:ln cap="flat" cmpd="sng" w="14300">
             <a:solidFill>
-              <a:srgbClr val="2563EB"/>
+              <a:srgbClr val="3B82F6"/>
             </a:solidFill>
             <a:prstDash val="solid"/>
             <a:round/>
@@ -18941,7 +19013,7 @@
             <a:r>
               <a:t/>
             </a:r>
-            <a:endParaRPr/>
+            <a:endParaRPr sz="1700"/>
           </a:p>
         </p:txBody>
       </p:sp>
@@ -18953,8 +19025,8 @@
         </p:nvSpPr>
         <p:spPr>
           <a:xfrm>
-            <a:off x="868680" y="1783080"/>
-            <a:ext cx="2286000" cy="1854900"/>
+            <a:off x="857250" y="1590675"/>
+            <a:ext cx="2238300" cy="1362300"/>
           </a:xfrm>
           <a:prstGeom prst="rect">
             <a:avLst/>
@@ -18969,7 +19041,7 @@
           </a:ln>
         </p:spPr>
         <p:txBody>
-          <a:bodyPr anchorCtr="0" anchor="t" bIns="38100" lIns="38100" spcFirstLastPara="1" rIns="38100" wrap="square" tIns="38100">
+          <a:bodyPr anchorCtr="0" anchor="t" bIns="0" lIns="0" spcFirstLastPara="1" rIns="0" wrap="square" tIns="0">
             <a:spAutoFit/>
           </a:bodyPr>
           <a:lstStyle/>
@@ -18984,43 +19056,31 @@
               <a:buNone/>
             </a:pPr>
             <a:r>
-              <a:rPr b="1" lang="en-US" sz="2300">
+              <a:rPr b="0" lang="en-US">
                 <a:solidFill>
                   <a:srgbClr val="2563EB"/>
                 </a:solidFill>
-                <a:latin typeface="Material Icons"/>
-                <a:ea typeface="Material Icons"/>
-                <a:cs typeface="Material Icons"/>
-                <a:sym typeface="Material Icons"/>
+                <a:latin typeface="Inter ExtraBold"/>
+                <a:ea typeface="Inter ExtraBold"/>
+                <a:cs typeface="Inter ExtraBold"/>
+                <a:sym typeface="Inter ExtraBold"/>
               </a:rPr>
-              <a:t>call_split</a:t>
+              <a:t>01. Split Stratifié 80/20</a:t>
             </a:r>
-            <a:r>
-              <a:rPr b="1" lang="en-US" sz="1800">
-                <a:solidFill>
-                  <a:srgbClr val="2563EB"/>
-                </a:solidFill>
-                <a:latin typeface="Calibri"/>
-                <a:ea typeface="Calibri"/>
-                <a:cs typeface="Calibri"/>
-                <a:sym typeface="Calibri"/>
-              </a:rPr>
-              <a:t> 1. Split Stratifié 80/20</a:t>
-            </a:r>
-            <a:endParaRPr b="1" sz="1800">
+            <a:endParaRPr b="0">
               <a:solidFill>
                 <a:srgbClr val="2563EB"/>
               </a:solidFill>
-              <a:latin typeface="Calibri"/>
-              <a:ea typeface="Calibri"/>
-              <a:cs typeface="Calibri"/>
-              <a:sym typeface="Calibri"/>
+              <a:latin typeface="Inter ExtraBold"/>
+              <a:ea typeface="Inter ExtraBold"/>
+              <a:cs typeface="Inter ExtraBold"/>
+              <a:sym typeface="Inter ExtraBold"/>
             </a:endParaRPr>
           </a:p>
           <a:p>
             <a:pPr indent="0" lvl="0" marL="0" rtl="0" algn="l">
               <a:spcBef>
-                <a:spcPts val="600"/>
+                <a:spcPts val="450"/>
               </a:spcBef>
               <a:spcAft>
                 <a:spcPts val="0"/>
@@ -19028,49 +19088,37 @@
               <a:buNone/>
             </a:pPr>
             <a:r>
-              <a:rPr b="0" lang="en-US" sz="1550">
-                <a:solidFill>
-                  <a:srgbClr val="334155"/>
-                </a:solidFill>
-                <a:latin typeface="Calibri"/>
-                <a:ea typeface="Calibri"/>
-                <a:cs typeface="Calibri"/>
-                <a:sym typeface="Calibri"/>
+              <a:rPr b="1" lang="en-US" sz="1600">
+                <a:solidFill>
+                  <a:srgbClr val="0F172A"/>
+                </a:solidFill>
+                <a:latin typeface="Inter"/>
+                <a:ea typeface="Inter"/>
+                <a:cs typeface="Inter"/>
+                <a:sym typeface="Inter"/>
               </a:rPr>
-              <a:t>• </a:t>
+              <a:t>• 227 664</a:t>
             </a:r>
             <a:r>
-              <a:rPr b="1" lang="en-US" sz="1550">
+              <a:rPr lang="en-US" sz="1600">
                 <a:solidFill>
                   <a:srgbClr val="334155"/>
                 </a:solidFill>
-                <a:latin typeface="Calibri"/>
-                <a:ea typeface="Calibri"/>
-                <a:cs typeface="Calibri"/>
-                <a:sym typeface="Calibri"/>
-              </a:rPr>
-              <a:t>227 664</a:t>
-            </a:r>
-            <a:r>
-              <a:rPr b="0" lang="en-US" sz="1550">
-                <a:solidFill>
-                  <a:srgbClr val="334155"/>
-                </a:solidFill>
-                <a:latin typeface="Calibri"/>
-                <a:ea typeface="Calibri"/>
-                <a:cs typeface="Calibri"/>
-                <a:sym typeface="Calibri"/>
+                <a:latin typeface="Inter"/>
+                <a:ea typeface="Inter"/>
+                <a:cs typeface="Inter"/>
+                <a:sym typeface="Inter"/>
               </a:rPr>
               <a:t> lignes d'entraînement</a:t>
             </a:r>
-            <a:endParaRPr b="0" sz="1550">
+            <a:endParaRPr sz="1600">
               <a:solidFill>
                 <a:srgbClr val="334155"/>
               </a:solidFill>
-              <a:latin typeface="Calibri"/>
-              <a:ea typeface="Calibri"/>
-              <a:cs typeface="Calibri"/>
-              <a:sym typeface="Calibri"/>
+              <a:latin typeface="Inter"/>
+              <a:ea typeface="Inter"/>
+              <a:cs typeface="Inter"/>
+              <a:sym typeface="Inter"/>
             </a:endParaRPr>
           </a:p>
           <a:p>
@@ -19084,55 +19132,43 @@
               <a:buNone/>
             </a:pPr>
             <a:r>
-              <a:rPr b="0" lang="en-US" sz="1550">
-                <a:solidFill>
-                  <a:srgbClr val="334155"/>
-                </a:solidFill>
-                <a:latin typeface="Calibri"/>
-                <a:ea typeface="Calibri"/>
-                <a:cs typeface="Calibri"/>
-                <a:sym typeface="Calibri"/>
+              <a:rPr b="1" lang="en-US" sz="1600">
+                <a:solidFill>
+                  <a:srgbClr val="0F172A"/>
+                </a:solidFill>
+                <a:latin typeface="Inter"/>
+                <a:ea typeface="Inter"/>
+                <a:cs typeface="Inter"/>
+                <a:sym typeface="Inter"/>
               </a:rPr>
-              <a:t>• </a:t>
+              <a:t>• 56 916</a:t>
             </a:r>
             <a:r>
-              <a:rPr b="1" lang="en-US" sz="1550">
+              <a:rPr lang="en-US" sz="1600">
                 <a:solidFill>
                   <a:srgbClr val="334155"/>
                 </a:solidFill>
-                <a:latin typeface="Calibri"/>
-                <a:ea typeface="Calibri"/>
-                <a:cs typeface="Calibri"/>
-                <a:sym typeface="Calibri"/>
-              </a:rPr>
-              <a:t>56 916</a:t>
-            </a:r>
-            <a:r>
-              <a:rPr b="0" lang="en-US" sz="1550">
-                <a:solidFill>
-                  <a:srgbClr val="334155"/>
-                </a:solidFill>
-                <a:latin typeface="Calibri"/>
-                <a:ea typeface="Calibri"/>
-                <a:cs typeface="Calibri"/>
-                <a:sym typeface="Calibri"/>
+                <a:latin typeface="Inter"/>
+                <a:ea typeface="Inter"/>
+                <a:cs typeface="Inter"/>
+                <a:sym typeface="Inter"/>
               </a:rPr>
               <a:t> de validation</a:t>
             </a:r>
-            <a:endParaRPr b="0" sz="1550">
+            <a:endParaRPr sz="1600">
               <a:solidFill>
                 <a:srgbClr val="334155"/>
               </a:solidFill>
-              <a:latin typeface="Calibri"/>
-              <a:ea typeface="Calibri"/>
-              <a:cs typeface="Calibri"/>
-              <a:sym typeface="Calibri"/>
+              <a:latin typeface="Inter"/>
+              <a:ea typeface="Inter"/>
+              <a:cs typeface="Inter"/>
+              <a:sym typeface="Inter"/>
             </a:endParaRPr>
           </a:p>
           <a:p>
             <a:pPr indent="0" lvl="0" marL="0" rtl="0" algn="l">
               <a:spcBef>
-                <a:spcPts val="450"/>
+                <a:spcPts val="600"/>
               </a:spcBef>
               <a:spcAft>
                 <a:spcPts val="0"/>
@@ -19140,25 +19176,25 @@
               <a:buNone/>
             </a:pPr>
             <a:r>
-              <a:rPr b="0" i="1" lang="en-US" sz="1550">
+              <a:rPr i="1" lang="en-US">
                 <a:solidFill>
                   <a:srgbClr val="64748B"/>
                 </a:solidFill>
-                <a:latin typeface="Calibri"/>
-                <a:ea typeface="Calibri"/>
-                <a:cs typeface="Calibri"/>
-                <a:sym typeface="Calibri"/>
+                <a:latin typeface="Inter"/>
+                <a:ea typeface="Inter"/>
+                <a:cs typeface="Inter"/>
+                <a:sym typeface="Inter"/>
               </a:rPr>
               <a:t>stratify=y préserve 3,23 %</a:t>
             </a:r>
-            <a:endParaRPr b="0" i="1" sz="1550">
+            <a:endParaRPr i="1">
               <a:solidFill>
                 <a:srgbClr val="64748B"/>
               </a:solidFill>
-              <a:latin typeface="Calibri"/>
-              <a:ea typeface="Calibri"/>
-              <a:cs typeface="Calibri"/>
-              <a:sym typeface="Calibri"/>
+              <a:latin typeface="Inter"/>
+              <a:ea typeface="Inter"/>
+              <a:cs typeface="Inter"/>
+              <a:sym typeface="Inter"/>
             </a:endParaRPr>
           </a:p>
         </p:txBody>
@@ -19171,12 +19207,12 @@
         </p:nvSpPr>
         <p:spPr>
           <a:xfrm>
-            <a:off x="3456432" y="1645920"/>
-            <a:ext cx="2560200" cy="2011800"/>
+            <a:off x="3467100" y="1476375"/>
+            <a:ext cx="2495700" cy="1857300"/>
           </a:xfrm>
           <a:prstGeom prst="roundRect">
             <a:avLst>
-              <a:gd fmla="val 7575" name="adj"/>
+              <a:gd fmla="val 6153" name="adj"/>
             </a:avLst>
           </a:prstGeom>
           <a:solidFill>
@@ -19217,7 +19253,7 @@
             <a:r>
               <a:t/>
             </a:r>
-            <a:endParaRPr/>
+            <a:endParaRPr sz="1700"/>
           </a:p>
         </p:txBody>
       </p:sp>
@@ -19229,8 +19265,8 @@
         </p:nvSpPr>
         <p:spPr>
           <a:xfrm>
-            <a:off x="3593542" y="1737030"/>
-            <a:ext cx="2286000" cy="1497000"/>
+            <a:off x="3590925" y="1590675"/>
+            <a:ext cx="2238300" cy="1227600"/>
           </a:xfrm>
           <a:prstGeom prst="rect">
             <a:avLst/>
@@ -19245,12 +19281,12 @@
           </a:ln>
         </p:spPr>
         <p:txBody>
-          <a:bodyPr anchorCtr="0" anchor="t" bIns="38100" lIns="38100" spcFirstLastPara="1" rIns="38100" wrap="square" tIns="38100">
+          <a:bodyPr anchorCtr="0" anchor="t" bIns="0" lIns="0" spcFirstLastPara="1" rIns="0" wrap="square" tIns="0">
             <a:spAutoFit/>
           </a:bodyPr>
           <a:lstStyle/>
           <a:p>
-            <a:pPr indent="0" lvl="0" marL="0" rtl="0" algn="ctr">
+            <a:pPr indent="0" lvl="0" marL="0" rtl="0" algn="l">
               <a:spcBef>
                 <a:spcPts val="0"/>
               </a:spcBef>
@@ -19260,43 +19296,31 @@
               <a:buNone/>
             </a:pPr>
             <a:r>
-              <a:rPr b="1" lang="en-US" sz="2300">
-                <a:solidFill>
-                  <a:srgbClr val="2563EB"/>
-                </a:solidFill>
-                <a:latin typeface="Material Icons"/>
-                <a:ea typeface="Material Icons"/>
-                <a:cs typeface="Material Icons"/>
-                <a:sym typeface="Material Icons"/>
+              <a:rPr b="0" lang="en-US">
+                <a:solidFill>
+                  <a:srgbClr val="475569"/>
+                </a:solidFill>
+                <a:latin typeface="Inter ExtraBold"/>
+                <a:ea typeface="Inter ExtraBold"/>
+                <a:cs typeface="Inter ExtraBold"/>
+                <a:sym typeface="Inter ExtraBold"/>
               </a:rPr>
-              <a:t>tune</a:t>
+              <a:t>02. StandardScaler</a:t>
             </a:r>
-            <a:r>
-              <a:rPr b="1" lang="en-US" sz="1800">
-                <a:solidFill>
-                  <a:srgbClr val="2563EB"/>
-                </a:solidFill>
-                <a:latin typeface="Calibri"/>
-                <a:ea typeface="Calibri"/>
-                <a:cs typeface="Calibri"/>
-                <a:sym typeface="Calibri"/>
-              </a:rPr>
-              <a:t> 2. StandardScaler</a:t>
-            </a:r>
-            <a:endParaRPr b="1" sz="1800">
+            <a:endParaRPr b="0">
               <a:solidFill>
-                <a:srgbClr val="2563EB"/>
+                <a:srgbClr val="475569"/>
               </a:solidFill>
-              <a:latin typeface="Calibri"/>
-              <a:ea typeface="Calibri"/>
-              <a:cs typeface="Calibri"/>
-              <a:sym typeface="Calibri"/>
+              <a:latin typeface="Inter ExtraBold"/>
+              <a:ea typeface="Inter ExtraBold"/>
+              <a:cs typeface="Inter ExtraBold"/>
+              <a:sym typeface="Inter ExtraBold"/>
             </a:endParaRPr>
           </a:p>
           <a:p>
-            <a:pPr indent="0" lvl="0" marL="0" rtl="0" algn="ctr">
-              <a:spcBef>
-                <a:spcPts val="600"/>
+            <a:pPr indent="0" lvl="0" marL="0" rtl="0" algn="l">
+              <a:spcBef>
+                <a:spcPts val="450"/>
               </a:spcBef>
               <a:spcAft>
                 <a:spcPts val="0"/>
@@ -19304,31 +19328,31 @@
               <a:buNone/>
             </a:pPr>
             <a:r>
-              <a:rPr b="0" lang="en-US" sz="1550">
-                <a:solidFill>
-                  <a:srgbClr val="334155"/>
-                </a:solidFill>
-                <a:latin typeface="Calibri"/>
-                <a:ea typeface="Calibri"/>
-                <a:cs typeface="Calibri"/>
-                <a:sym typeface="Calibri"/>
+              <a:rPr lang="en-US" sz="1500">
+                <a:solidFill>
+                  <a:srgbClr val="475569"/>
+                </a:solidFill>
+                <a:latin typeface="Inter"/>
+                <a:ea typeface="Inter"/>
+                <a:cs typeface="Inter"/>
+                <a:sym typeface="Inter"/>
               </a:rPr>
               <a:t>Variables numériques :</a:t>
             </a:r>
-            <a:endParaRPr b="0" sz="1550">
+            <a:endParaRPr sz="1500">
               <a:solidFill>
-                <a:srgbClr val="334155"/>
+                <a:srgbClr val="475569"/>
               </a:solidFill>
-              <a:latin typeface="Calibri"/>
-              <a:ea typeface="Calibri"/>
-              <a:cs typeface="Calibri"/>
-              <a:sym typeface="Calibri"/>
+              <a:latin typeface="Inter"/>
+              <a:ea typeface="Inter"/>
+              <a:cs typeface="Inter"/>
+              <a:sym typeface="Inter"/>
             </a:endParaRPr>
           </a:p>
           <a:p>
-            <a:pPr indent="0" lvl="0" marL="0" rtl="0" algn="ctr">
-              <a:spcBef>
-                <a:spcPts val="450"/>
+            <a:pPr indent="0" lvl="0" marL="0" rtl="0" algn="l">
+              <a:spcBef>
+                <a:spcPts val="600"/>
               </a:spcBef>
               <a:spcAft>
                 <a:spcPts val="0"/>
@@ -19336,27 +19360,67 @@
               <a:buNone/>
             </a:pPr>
             <a:r>
-              <a:rPr b="1" lang="en-US" sz="1500">
-                <a:solidFill>
-                  <a:srgbClr val="1E293B"/>
-                </a:solidFill>
-                <a:highlight>
-                  <a:srgbClr val="F1F5F9"/>
-                </a:highlight>
+              <a:rPr lang="en-US">
+                <a:solidFill>
+                  <a:srgbClr val="0F172A"/>
+                </a:solidFill>
                 <a:latin typeface="Consolas"/>
                 <a:ea typeface="Consolas"/>
                 <a:cs typeface="Consolas"/>
                 <a:sym typeface="Consolas"/>
               </a:rPr>
-              <a:t>age, total_pages_visited, new_user</a:t>
+              <a:t>age,</a:t>
             </a:r>
-            <a:endParaRPr b="1" sz="1500">
+            <a:br>
+              <a:rPr lang="en-US">
+                <a:solidFill>
+                  <a:srgbClr val="0F172A"/>
+                </a:solidFill>
+                <a:latin typeface="Consolas"/>
+                <a:ea typeface="Consolas"/>
+                <a:cs typeface="Consolas"/>
+                <a:sym typeface="Consolas"/>
+              </a:rPr>
+            </a:br>
+            <a:r>
+              <a:rPr lang="en-US">
+                <a:solidFill>
+                  <a:srgbClr val="0F172A"/>
+                </a:solidFill>
+                <a:latin typeface="Consolas"/>
+                <a:ea typeface="Consolas"/>
+                <a:cs typeface="Consolas"/>
+                <a:sym typeface="Consolas"/>
+              </a:rPr>
+              <a:t>total_pages_visited,</a:t>
+            </a:r>
+            <a:br>
+              <a:rPr lang="en-US">
+                <a:solidFill>
+                  <a:srgbClr val="0F172A"/>
+                </a:solidFill>
+                <a:latin typeface="Consolas"/>
+                <a:ea typeface="Consolas"/>
+                <a:cs typeface="Consolas"/>
+                <a:sym typeface="Consolas"/>
+              </a:rPr>
+            </a:br>
+            <a:r>
+              <a:rPr lang="en-US">
+                <a:solidFill>
+                  <a:srgbClr val="0F172A"/>
+                </a:solidFill>
+                <a:latin typeface="Consolas"/>
+                <a:ea typeface="Consolas"/>
+                <a:cs typeface="Consolas"/>
+                <a:sym typeface="Consolas"/>
+              </a:rPr>
+              <a:t>new_user</a:t>
+            </a:r>
+            <a:endParaRPr>
               <a:solidFill>
-                <a:srgbClr val="1E293B"/>
+                <a:srgbClr val="0F172A"/>
               </a:solidFill>
-              <a:highlight>
-                <a:srgbClr val="F1F5F9"/>
-              </a:highlight>
               <a:latin typeface="Consolas"/>
               <a:ea typeface="Consolas"/>
               <a:cs typeface="Consolas"/>
@@ -19373,12 +19437,12 @@
         </p:nvSpPr>
         <p:spPr>
           <a:xfrm>
-            <a:off x="6181344" y="1645920"/>
-            <a:ext cx="2560200" cy="2011800"/>
+            <a:off x="6200775" y="1476375"/>
+            <a:ext cx="2495700" cy="1857300"/>
           </a:xfrm>
           <a:prstGeom prst="roundRect">
             <a:avLst>
-              <a:gd fmla="val 7575" name="adj"/>
+              <a:gd fmla="val 6153" name="adj"/>
             </a:avLst>
           </a:prstGeom>
           <a:solidFill>
@@ -19419,7 +19483,7 @@
             <a:r>
               <a:t/>
             </a:r>
-            <a:endParaRPr/>
+            <a:endParaRPr sz="1700"/>
           </a:p>
         </p:txBody>
       </p:sp>
@@ -19431,8 +19495,8 @@
         </p:nvSpPr>
         <p:spPr>
           <a:xfrm>
-            <a:off x="6318504" y="1783080"/>
-            <a:ext cx="2286000" cy="1027500"/>
+            <a:off x="6324600" y="1590675"/>
+            <a:ext cx="2238300" cy="1012200"/>
           </a:xfrm>
           <a:prstGeom prst="rect">
             <a:avLst/>
@@ -19447,12 +19511,12 @@
           </a:ln>
         </p:spPr>
         <p:txBody>
-          <a:bodyPr anchorCtr="0" anchor="t" bIns="38100" lIns="38100" spcFirstLastPara="1" rIns="38100" wrap="square" tIns="38100">
+          <a:bodyPr anchorCtr="0" anchor="t" bIns="0" lIns="0" spcFirstLastPara="1" rIns="0" wrap="square" tIns="0">
             <a:spAutoFit/>
           </a:bodyPr>
           <a:lstStyle/>
           <a:p>
-            <a:pPr indent="0" lvl="0" marL="0" rtl="0" algn="ctr">
+            <a:pPr indent="0" lvl="0" marL="0" rtl="0" algn="l">
               <a:spcBef>
                 <a:spcPts val="0"/>
               </a:spcBef>
@@ -19462,43 +19526,31 @@
               <a:buNone/>
             </a:pPr>
             <a:r>
-              <a:rPr b="1" lang="en-US" sz="2300">
-                <a:solidFill>
-                  <a:srgbClr val="2563EB"/>
-                </a:solidFill>
-                <a:latin typeface="Material Icons"/>
-                <a:ea typeface="Material Icons"/>
-                <a:cs typeface="Material Icons"/>
-                <a:sym typeface="Material Icons"/>
+              <a:rPr b="0" lang="en-US">
+                <a:solidFill>
+                  <a:srgbClr val="475569"/>
+                </a:solidFill>
+                <a:latin typeface="Inter ExtraBold"/>
+                <a:ea typeface="Inter ExtraBold"/>
+                <a:cs typeface="Inter ExtraBold"/>
+                <a:sym typeface="Inter ExtraBold"/>
               </a:rPr>
-              <a:t>category</a:t>
+              <a:t>03. OneHotEncoder</a:t>
             </a:r>
-            <a:r>
-              <a:rPr b="1" lang="en-US" sz="1800">
-                <a:solidFill>
-                  <a:srgbClr val="2563EB"/>
-                </a:solidFill>
-                <a:latin typeface="Calibri"/>
-                <a:ea typeface="Calibri"/>
-                <a:cs typeface="Calibri"/>
-                <a:sym typeface="Calibri"/>
-              </a:rPr>
-              <a:t> 3. OneHotEncoder</a:t>
-            </a:r>
-            <a:endParaRPr b="1" sz="1800">
+            <a:endParaRPr b="0">
               <a:solidFill>
-                <a:srgbClr val="2563EB"/>
+                <a:srgbClr val="475569"/>
               </a:solidFill>
-              <a:latin typeface="Calibri"/>
-              <a:ea typeface="Calibri"/>
-              <a:cs typeface="Calibri"/>
-              <a:sym typeface="Calibri"/>
+              <a:latin typeface="Inter ExtraBold"/>
+              <a:ea typeface="Inter ExtraBold"/>
+              <a:cs typeface="Inter ExtraBold"/>
+              <a:sym typeface="Inter ExtraBold"/>
             </a:endParaRPr>
           </a:p>
           <a:p>
-            <a:pPr indent="0" lvl="0" marL="0" rtl="0" algn="ctr">
-              <a:spcBef>
-                <a:spcPts val="600"/>
+            <a:pPr indent="0" lvl="0" marL="0" rtl="0" algn="l">
+              <a:spcBef>
+                <a:spcPts val="450"/>
               </a:spcBef>
               <a:spcAft>
                 <a:spcPts val="0"/>
@@ -19506,83 +19558,76 @@
               <a:buNone/>
             </a:pPr>
             <a:r>
-              <a:rPr b="0" lang="en-US" sz="1550">
-                <a:solidFill>
-                  <a:srgbClr val="334155"/>
-                </a:solidFill>
-                <a:latin typeface="Calibri"/>
-                <a:ea typeface="Calibri"/>
-                <a:cs typeface="Calibri"/>
-                <a:sym typeface="Calibri"/>
+              <a:rPr lang="en-US" sz="1500">
+                <a:solidFill>
+                  <a:srgbClr val="475569"/>
+                </a:solidFill>
+                <a:latin typeface="Inter"/>
+                <a:ea typeface="Inter"/>
+                <a:cs typeface="Inter"/>
+                <a:sym typeface="Inter"/>
               </a:rPr>
-              <a:t>Sur </a:t>
+              <a:t>Variables catégorielles :</a:t>
             </a:r>
+            <a:endParaRPr sz="1500">
+              <a:solidFill>
+                <a:srgbClr val="475569"/>
+              </a:solidFill>
+              <a:latin typeface="Inter"/>
+              <a:ea typeface="Inter"/>
+              <a:cs typeface="Inter"/>
+              <a:sym typeface="Inter"/>
+            </a:endParaRPr>
+          </a:p>
+          <a:p>
+            <a:pPr indent="0" lvl="0" marL="0" rtl="0" algn="l">
+              <a:spcBef>
+                <a:spcPts val="600"/>
+              </a:spcBef>
+              <a:spcAft>
+                <a:spcPts val="0"/>
+              </a:spcAft>
+              <a:buNone/>
+            </a:pPr>
             <a:r>
-              <a:rPr b="1" lang="en-US" sz="1550">
-                <a:solidFill>
-                  <a:srgbClr val="334155"/>
-                </a:solidFill>
-                <a:latin typeface="Calibri"/>
-                <a:ea typeface="Calibri"/>
-                <a:cs typeface="Calibri"/>
-                <a:sym typeface="Calibri"/>
+              <a:rPr lang="en-US">
+                <a:solidFill>
+                  <a:srgbClr val="0F172A"/>
+                </a:solidFill>
+                <a:latin typeface="Consolas"/>
+                <a:ea typeface="Consolas"/>
+                <a:cs typeface="Consolas"/>
+                <a:sym typeface="Consolas"/>
               </a:rPr>
-              <a:t>country</a:t>
+              <a:t>country &amp;</a:t>
             </a:r>
+            <a:br>
+              <a:rPr lang="en-US">
+                <a:solidFill>
+                  <a:srgbClr val="0F172A"/>
+                </a:solidFill>
+                <a:latin typeface="Consolas"/>
+                <a:ea typeface="Consolas"/>
+                <a:cs typeface="Consolas"/>
+                <a:sym typeface="Consolas"/>
+              </a:rPr>
+            </a:br>
             <a:r>
-              <a:rPr b="0" lang="en-US" sz="1550">
-                <a:solidFill>
-                  <a:srgbClr val="334155"/>
-                </a:solidFill>
-                <a:latin typeface="Calibri"/>
-                <a:ea typeface="Calibri"/>
-                <a:cs typeface="Calibri"/>
-                <a:sym typeface="Calibri"/>
-              </a:rPr>
-              <a:t> &amp; </a:t>
-            </a:r>
-            <a:r>
-              <a:rPr b="1" lang="en-US" sz="1550">
-                <a:solidFill>
-                  <a:srgbClr val="334155"/>
-                </a:solidFill>
-                <a:latin typeface="Calibri"/>
-                <a:ea typeface="Calibri"/>
-                <a:cs typeface="Calibri"/>
-                <a:sym typeface="Calibri"/>
+              <a:rPr lang="en-US">
+                <a:solidFill>
+                  <a:srgbClr val="0F172A"/>
+                </a:solidFill>
+                <a:latin typeface="Consolas"/>
+                <a:ea typeface="Consolas"/>
+                <a:cs typeface="Consolas"/>
+                <a:sym typeface="Consolas"/>
               </a:rPr>
               <a:t>source</a:t>
             </a:r>
-            <a:endParaRPr b="0" sz="1550">
+            <a:endParaRPr>
               <a:solidFill>
-                <a:srgbClr val="334155"/>
+                <a:srgbClr val="0F172A"/>
               </a:solidFill>
-              <a:latin typeface="Calibri"/>
-              <a:ea typeface="Calibri"/>
-              <a:cs typeface="Calibri"/>
-              <a:sym typeface="Calibri"/>
-            </a:endParaRPr>
-          </a:p>
-          <a:p>
-            <a:pPr indent="0" lvl="0" marL="0" rtl="0" algn="ctr">
-              <a:spcBef>
-                <a:spcPts val="450"/>
-              </a:spcBef>
-              <a:spcAft>
-                <a:spcPts val="0"/>
-              </a:spcAft>
-              <a:buNone/>
-            </a:pPr>
-            <a:r>
-              <a:t/>
-            </a:r>
-            <a:endParaRPr b="1" sz="1450">
-              <a:solidFill>
-                <a:srgbClr val="1E293B"/>
-              </a:solidFill>
-              <a:highlight>
-                <a:srgbClr val="F1F5F9"/>
-              </a:highlight>
               <a:latin typeface="Consolas"/>
               <a:ea typeface="Consolas"/>
               <a:cs typeface="Consolas"/>
@@ -19599,20 +19644,20 @@
         </p:nvSpPr>
         <p:spPr>
           <a:xfrm>
-            <a:off x="8906256" y="1645920"/>
-            <a:ext cx="2560200" cy="2011800"/>
+            <a:off x="8934450" y="1476375"/>
+            <a:ext cx="2495700" cy="1857300"/>
           </a:xfrm>
           <a:prstGeom prst="roundRect">
             <a:avLst>
-              <a:gd fmla="val 7575" name="adj"/>
+              <a:gd fmla="val 6153" name="adj"/>
             </a:avLst>
           </a:prstGeom>
           <a:solidFill>
             <a:srgbClr val="ECFDF5"/>
           </a:solidFill>
-          <a:ln cap="flat" cmpd="sng" w="14300">
+          <a:ln cap="flat" cmpd="sng" w="19050">
             <a:solidFill>
-              <a:srgbClr val="059669"/>
+              <a:srgbClr val="10B981"/>
             </a:solidFill>
             <a:prstDash val="solid"/>
             <a:round/>
@@ -19645,7 +19690,7 @@
             <a:r>
               <a:t/>
             </a:r>
-            <a:endParaRPr/>
+            <a:endParaRPr sz="1700"/>
           </a:p>
         </p:txBody>
       </p:sp>
@@ -19657,8 +19702,8 @@
         </p:nvSpPr>
         <p:spPr>
           <a:xfrm>
-            <a:off x="9043416" y="1783080"/>
-            <a:ext cx="2286000" cy="1797000"/>
+            <a:off x="9058275" y="1590675"/>
+            <a:ext cx="2238300" cy="1312200"/>
           </a:xfrm>
           <a:prstGeom prst="rect">
             <a:avLst/>
@@ -19673,7 +19718,7 @@
           </a:ln>
         </p:spPr>
         <p:txBody>
-          <a:bodyPr anchorCtr="0" anchor="t" bIns="38100" lIns="38100" spcFirstLastPara="1" rIns="38100" wrap="square" tIns="38100">
+          <a:bodyPr anchorCtr="0" anchor="t" bIns="0" lIns="0" spcFirstLastPara="1" rIns="0" wrap="square" tIns="0">
             <a:spAutoFit/>
           </a:bodyPr>
           <a:lstStyle/>
@@ -19688,37 +19733,25 @@
               <a:buNone/>
             </a:pPr>
             <a:r>
-              <a:rPr b="1" lang="en-US" sz="2300">
+              <a:rPr b="0" lang="en-US">
                 <a:solidFill>
                   <a:srgbClr val="059669"/>
                 </a:solidFill>
-                <a:latin typeface="Material Icons"/>
-                <a:ea typeface="Material Icons"/>
-                <a:cs typeface="Material Icons"/>
-                <a:sym typeface="Material Icons"/>
+                <a:latin typeface="Inter ExtraBold"/>
+                <a:ea typeface="Inter ExtraBold"/>
+                <a:cs typeface="Inter ExtraBold"/>
+                <a:sym typeface="Inter ExtraBold"/>
               </a:rPr>
-              <a:t>verified_user</a:t>
+              <a:t>04. Pipeline Scikit-Learn</a:t>
             </a:r>
-            <a:r>
-              <a:rPr b="1" lang="en-US" sz="1800">
-                <a:solidFill>
-                  <a:srgbClr val="059669"/>
-                </a:solidFill>
-                <a:latin typeface="Calibri"/>
-                <a:ea typeface="Calibri"/>
-                <a:cs typeface="Calibri"/>
-                <a:sym typeface="Calibri"/>
-              </a:rPr>
-              <a:t> 4. Pipeline Scikit-Learn</a:t>
-            </a:r>
-            <a:endParaRPr b="1" sz="1800">
+            <a:endParaRPr b="0">
               <a:solidFill>
                 <a:srgbClr val="059669"/>
               </a:solidFill>
-              <a:latin typeface="Calibri"/>
-              <a:ea typeface="Calibri"/>
-              <a:cs typeface="Calibri"/>
-              <a:sym typeface="Calibri"/>
+              <a:latin typeface="Inter ExtraBold"/>
+              <a:ea typeface="Inter ExtraBold"/>
+              <a:cs typeface="Inter ExtraBold"/>
+              <a:sym typeface="Inter ExtraBold"/>
             </a:endParaRPr>
           </a:p>
           <a:p>
@@ -19732,31 +19765,31 @@
               <a:buNone/>
             </a:pPr>
             <a:r>
-              <a:rPr b="0" lang="en-US" sz="1550">
+              <a:rPr lang="en-US" sz="1500">
                 <a:solidFill>
                   <a:srgbClr val="065F46"/>
                 </a:solidFill>
-                <a:latin typeface="Calibri"/>
-                <a:ea typeface="Calibri"/>
-                <a:cs typeface="Calibri"/>
-                <a:sym typeface="Calibri"/>
+                <a:latin typeface="Inter"/>
+                <a:ea typeface="Inter"/>
+                <a:cs typeface="Inter"/>
+                <a:sym typeface="Inter"/>
               </a:rPr>
               <a:t>• Intègre préprocesseur + estimateur</a:t>
             </a:r>
-            <a:endParaRPr b="0" sz="1550">
+            <a:endParaRPr sz="1500">
               <a:solidFill>
                 <a:srgbClr val="065F46"/>
               </a:solidFill>
-              <a:latin typeface="Calibri"/>
-              <a:ea typeface="Calibri"/>
-              <a:cs typeface="Calibri"/>
-              <a:sym typeface="Calibri"/>
+              <a:latin typeface="Inter"/>
+              <a:ea typeface="Inter"/>
+              <a:cs typeface="Inter"/>
+              <a:sym typeface="Inter"/>
             </a:endParaRPr>
           </a:p>
           <a:p>
             <a:pPr indent="0" lvl="0" marL="0" rtl="0" algn="l">
               <a:spcBef>
-                <a:spcPts val="450"/>
+                <a:spcPts val="750"/>
               </a:spcBef>
               <a:spcAft>
                 <a:spcPts val="0"/>
@@ -19764,25 +19797,25 @@
               <a:buNone/>
             </a:pPr>
             <a:r>
-              <a:rPr b="1" lang="en-US" sz="1550">
+              <a:rPr b="1" lang="en-US" sz="1500">
                 <a:solidFill>
                   <a:srgbClr val="047857"/>
                 </a:solidFill>
-                <a:latin typeface="Calibri"/>
-                <a:ea typeface="Calibri"/>
-                <a:cs typeface="Calibri"/>
-                <a:sym typeface="Calibri"/>
+                <a:latin typeface="Inter"/>
+                <a:ea typeface="Inter"/>
+                <a:cs typeface="Inter"/>
+                <a:sym typeface="Inter"/>
               </a:rPr>
               <a:t>✓ Aucune fuite de données</a:t>
             </a:r>
-            <a:endParaRPr b="1" sz="1550">
+            <a:endParaRPr b="1" sz="1500">
               <a:solidFill>
                 <a:srgbClr val="047857"/>
               </a:solidFill>
-              <a:latin typeface="Calibri"/>
-              <a:ea typeface="Calibri"/>
-              <a:cs typeface="Calibri"/>
-              <a:sym typeface="Calibri"/>
+              <a:latin typeface="Inter"/>
+              <a:ea typeface="Inter"/>
+              <a:cs typeface="Inter"/>
+              <a:sym typeface="Inter"/>
             </a:endParaRPr>
           </a:p>
         </p:txBody>
@@ -19795,12 +19828,12 @@
         </p:nvSpPr>
         <p:spPr>
           <a:xfrm>
-            <a:off x="731520" y="3886200"/>
-            <a:ext cx="5212200" cy="2240400"/>
+            <a:off x="731520" y="3524250"/>
+            <a:ext cx="5219700" cy="2667000"/>
           </a:xfrm>
           <a:prstGeom prst="roundRect">
             <a:avLst>
-              <a:gd fmla="val 8503" name="adj"/>
+              <a:gd fmla="val 5714" name="adj"/>
             </a:avLst>
           </a:prstGeom>
           <a:solidFill>
@@ -19841,7 +19874,7 @@
             <a:r>
               <a:t/>
             </a:r>
-            <a:endParaRPr/>
+            <a:endParaRPr sz="1700"/>
           </a:p>
         </p:txBody>
       </p:sp>
@@ -19853,8 +19886,8 @@
         </p:nvSpPr>
         <p:spPr>
           <a:xfrm>
-            <a:off x="914400" y="4023360"/>
-            <a:ext cx="4846200" cy="1854900"/>
+            <a:off x="914400" y="3695700"/>
+            <a:ext cx="4848300" cy="2197200"/>
           </a:xfrm>
           <a:prstGeom prst="rect">
             <a:avLst/>
@@ -19869,7 +19902,7 @@
           </a:ln>
         </p:spPr>
         <p:txBody>
-          <a:bodyPr anchorCtr="0" anchor="t" bIns="38100" lIns="38100" spcFirstLastPara="1" rIns="38100" wrap="square" tIns="38100">
+          <a:bodyPr anchorCtr="0" anchor="t" bIns="0" lIns="0" spcFirstLastPara="1" rIns="0" wrap="square" tIns="0">
             <a:spAutoFit/>
           </a:bodyPr>
           <a:lstStyle/>
@@ -19888,10 +19921,10 @@
                 <a:solidFill>
                   <a:srgbClr val="334155"/>
                 </a:solidFill>
-                <a:latin typeface="Calibri"/>
-                <a:ea typeface="Calibri"/>
-                <a:cs typeface="Calibri"/>
-                <a:sym typeface="Calibri"/>
+                <a:latin typeface="Inter"/>
+                <a:ea typeface="Inter"/>
+                <a:cs typeface="Inter"/>
+                <a:sym typeface="Inter"/>
               </a:rPr>
               <a:t>Modèle 0 : Baseline 1 Variable (Pages vues)</a:t>
             </a:r>
@@ -19899,16 +19932,16 @@
               <a:solidFill>
                 <a:srgbClr val="334155"/>
               </a:solidFill>
-              <a:latin typeface="Calibri"/>
-              <a:ea typeface="Calibri"/>
-              <a:cs typeface="Calibri"/>
-              <a:sym typeface="Calibri"/>
+              <a:latin typeface="Inter"/>
+              <a:ea typeface="Inter"/>
+              <a:cs typeface="Inter"/>
+              <a:sym typeface="Inter"/>
             </a:endParaRPr>
           </a:p>
           <a:p>
             <a:pPr indent="0" lvl="0" marL="0" rtl="0" algn="l">
               <a:spcBef>
-                <a:spcPts val="750"/>
+                <a:spcPts val="900"/>
               </a:spcBef>
               <a:spcAft>
                 <a:spcPts val="0"/>
@@ -19916,88 +19949,70 @@
               <a:buNone/>
             </a:pPr>
             <a:r>
-              <a:rPr b="0" lang="en-US" sz="1500">
-                <a:solidFill>
-                  <a:srgbClr val="1E293B"/>
-                </a:solidFill>
-                <a:highlight>
-                  <a:srgbClr val="E2E8F0"/>
-                </a:highlight>
-                <a:latin typeface="Calibri"/>
-                <a:ea typeface="Calibri"/>
-                <a:cs typeface="Calibri"/>
-                <a:sym typeface="Calibri"/>
+              <a:rPr b="1" lang="en-US">
+                <a:solidFill>
+                  <a:srgbClr val="0F172A"/>
+                </a:solidFill>
+                <a:latin typeface="Inter"/>
+                <a:ea typeface="Inter"/>
+                <a:cs typeface="Inter"/>
+                <a:sym typeface="Inter"/>
               </a:rPr>
               <a:t>F1-Score: 0,7055</a:t>
             </a:r>
             <a:r>
-              <a:rPr b="0" lang="en-US" sz="1500">
-                <a:solidFill>
-                  <a:srgbClr val="0F172A"/>
-                </a:solidFill>
-                <a:latin typeface="Calibri"/>
-                <a:ea typeface="Calibri"/>
-                <a:cs typeface="Calibri"/>
-                <a:sym typeface="Calibri"/>
+              <a:rPr lang="en-US" sz="1700">
+                <a:latin typeface="Inter"/>
+                <a:ea typeface="Inter"/>
+                <a:cs typeface="Inter"/>
+                <a:sym typeface="Inter"/>
               </a:rPr>
               <a:t> </a:t>
             </a:r>
             <a:r>
-              <a:rPr b="0" lang="en-US" sz="1500">
-                <a:solidFill>
-                  <a:srgbClr val="1E293B"/>
-                </a:solidFill>
-                <a:highlight>
-                  <a:srgbClr val="E2E8F0"/>
-                </a:highlight>
-                <a:latin typeface="Calibri"/>
-                <a:ea typeface="Calibri"/>
-                <a:cs typeface="Calibri"/>
-                <a:sym typeface="Calibri"/>
+              <a:rPr lang="en-US">
+                <a:solidFill>
+                  <a:srgbClr val="334155"/>
+                </a:solidFill>
+                <a:latin typeface="Inter"/>
+                <a:ea typeface="Inter"/>
+                <a:cs typeface="Inter"/>
+                <a:sym typeface="Inter"/>
               </a:rPr>
               <a:t>Rappel: 61,06 %</a:t>
             </a:r>
             <a:r>
-              <a:rPr b="0" lang="en-US" sz="1500">
-                <a:solidFill>
-                  <a:srgbClr val="0F172A"/>
-                </a:solidFill>
-                <a:latin typeface="Calibri"/>
-                <a:ea typeface="Calibri"/>
-                <a:cs typeface="Calibri"/>
-                <a:sym typeface="Calibri"/>
+              <a:rPr lang="en-US" sz="1700">
+                <a:latin typeface="Inter"/>
+                <a:ea typeface="Inter"/>
+                <a:cs typeface="Inter"/>
+                <a:sym typeface="Inter"/>
               </a:rPr>
               <a:t> </a:t>
             </a:r>
             <a:r>
-              <a:rPr b="0" lang="en-US" sz="1500">
-                <a:solidFill>
-                  <a:srgbClr val="1E293B"/>
-                </a:solidFill>
-                <a:highlight>
-                  <a:srgbClr val="E2E8F0"/>
-                </a:highlight>
-                <a:latin typeface="Calibri"/>
-                <a:ea typeface="Calibri"/>
-                <a:cs typeface="Calibri"/>
-                <a:sym typeface="Calibri"/>
+              <a:rPr lang="en-US">
+                <a:solidFill>
+                  <a:srgbClr val="334155"/>
+                </a:solidFill>
+                <a:latin typeface="Inter"/>
+                <a:ea typeface="Inter"/>
+                <a:cs typeface="Inter"/>
+                <a:sym typeface="Inter"/>
               </a:rPr>
               <a:t>Précision: 83,53 %</a:t>
             </a:r>
-            <a:endParaRPr b="0" sz="1500">
-              <a:solidFill>
-                <a:srgbClr val="0F172A"/>
-              </a:solidFill>
-              <a:latin typeface="Calibri"/>
-              <a:ea typeface="Calibri"/>
-              <a:cs typeface="Calibri"/>
-              <a:sym typeface="Calibri"/>
+            <a:endParaRPr sz="1700">
+              <a:latin typeface="Inter"/>
+              <a:ea typeface="Inter"/>
+              <a:cs typeface="Inter"/>
+              <a:sym typeface="Inter"/>
             </a:endParaRPr>
           </a:p>
           <a:p>
             <a:pPr indent="0" lvl="0" marL="0" rtl="0" algn="l">
               <a:spcBef>
-                <a:spcPts val="900"/>
+                <a:spcPts val="1200"/>
               </a:spcBef>
               <a:spcAft>
                 <a:spcPts val="0"/>
@@ -20005,31 +20020,31 @@
               <a:buNone/>
             </a:pPr>
             <a:r>
-              <a:rPr b="0" lang="en-US" sz="1600">
+              <a:rPr lang="en-US" sz="1600">
                 <a:solidFill>
                   <a:srgbClr val="475569"/>
                 </a:solidFill>
-                <a:latin typeface="Calibri"/>
-                <a:ea typeface="Calibri"/>
-                <a:cs typeface="Calibri"/>
-                <a:sym typeface="Calibri"/>
+                <a:latin typeface="Inter"/>
+                <a:ea typeface="Inter"/>
+                <a:cs typeface="Inter"/>
+                <a:sym typeface="Inter"/>
               </a:rPr>
               <a:t>• Prouve immédiatement que la variable pages vues porte l'essentiel du signal.</a:t>
             </a:r>
-            <a:endParaRPr b="0" sz="1600">
+            <a:endParaRPr sz="1600">
               <a:solidFill>
                 <a:srgbClr val="475569"/>
               </a:solidFill>
-              <a:latin typeface="Calibri"/>
-              <a:ea typeface="Calibri"/>
-              <a:cs typeface="Calibri"/>
-              <a:sym typeface="Calibri"/>
+              <a:latin typeface="Inter"/>
+              <a:ea typeface="Inter"/>
+              <a:cs typeface="Inter"/>
+              <a:sym typeface="Inter"/>
             </a:endParaRPr>
           </a:p>
           <a:p>
             <a:pPr indent="0" lvl="0" marL="0" rtl="0" algn="l">
               <a:spcBef>
-                <a:spcPts val="450"/>
+                <a:spcPts val="750"/>
               </a:spcBef>
               <a:spcAft>
                 <a:spcPts val="0"/>
@@ -20037,25 +20052,25 @@
               <a:buNone/>
             </a:pPr>
             <a:r>
-              <a:rPr b="0" lang="en-US" sz="1600">
+              <a:rPr lang="en-US" sz="1600">
                 <a:solidFill>
                   <a:srgbClr val="475569"/>
                 </a:solidFill>
-                <a:latin typeface="Calibri"/>
-                <a:ea typeface="Calibri"/>
-                <a:cs typeface="Calibri"/>
-                <a:sym typeface="Calibri"/>
+                <a:latin typeface="Inter"/>
+                <a:ea typeface="Inter"/>
+                <a:cs typeface="Inter"/>
+                <a:sym typeface="Inter"/>
               </a:rPr>
               <a:t>• Sert de repère minimal imposé par le template du challenge.</a:t>
             </a:r>
-            <a:endParaRPr b="0" sz="1600">
+            <a:endParaRPr sz="1600">
               <a:solidFill>
                 <a:srgbClr val="475569"/>
               </a:solidFill>
-              <a:latin typeface="Calibri"/>
-              <a:ea typeface="Calibri"/>
-              <a:cs typeface="Calibri"/>
-              <a:sym typeface="Calibri"/>
+              <a:latin typeface="Inter"/>
+              <a:ea typeface="Inter"/>
+              <a:cs typeface="Inter"/>
+              <a:sym typeface="Inter"/>
             </a:endParaRPr>
           </a:p>
         </p:txBody>
@@ -20068,12 +20083,12 @@
         </p:nvSpPr>
         <p:spPr>
           <a:xfrm>
-            <a:off x="6217920" y="3886200"/>
-            <a:ext cx="5242200" cy="2240400"/>
+            <a:off x="6200775" y="3524250"/>
+            <a:ext cx="5248200" cy="2667000"/>
           </a:xfrm>
           <a:prstGeom prst="roundRect">
             <a:avLst>
-              <a:gd fmla="val 8503" name="adj"/>
+              <a:gd fmla="val 5714" name="adj"/>
             </a:avLst>
           </a:prstGeom>
           <a:solidFill>
@@ -20081,7 +20096,7 @@
           </a:solidFill>
           <a:ln cap="flat" cmpd="sng" w="19050">
             <a:solidFill>
-              <a:srgbClr val="3B82F6"/>
+              <a:srgbClr val="2563EB"/>
             </a:solidFill>
             <a:prstDash val="solid"/>
             <a:round/>
@@ -20114,7 +20129,7 @@
             <a:r>
               <a:t/>
             </a:r>
-            <a:endParaRPr/>
+            <a:endParaRPr sz="1700"/>
           </a:p>
         </p:txBody>
       </p:sp>
@@ -20126,8 +20141,8 @@
         </p:nvSpPr>
         <p:spPr>
           <a:xfrm>
-            <a:off x="6400800" y="4023360"/>
-            <a:ext cx="4876500" cy="1508400"/>
+            <a:off x="6381750" y="3695700"/>
+            <a:ext cx="4876800" cy="2085600"/>
           </a:xfrm>
           <a:prstGeom prst="rect">
             <a:avLst/>
@@ -20142,7 +20157,7 @@
           </a:ln>
         </p:spPr>
         <p:txBody>
-          <a:bodyPr anchorCtr="0" anchor="t" bIns="38100" lIns="38100" spcFirstLastPara="1" rIns="38100" wrap="square" tIns="38100">
+          <a:bodyPr anchorCtr="0" anchor="t" bIns="0" lIns="0" spcFirstLastPara="1" rIns="0" wrap="square" tIns="0">
             <a:spAutoFit/>
           </a:bodyPr>
           <a:lstStyle/>
@@ -20157,31 +20172,31 @@
               <a:buNone/>
             </a:pPr>
             <a:r>
-              <a:rPr b="1" lang="en-US" sz="1800">
+              <a:rPr b="0" lang="en-US" sz="1900">
                 <a:solidFill>
                   <a:srgbClr val="1D4ED8"/>
                 </a:solidFill>
-                <a:latin typeface="Calibri"/>
-                <a:ea typeface="Calibri"/>
-                <a:cs typeface="Calibri"/>
-                <a:sym typeface="Calibri"/>
+                <a:latin typeface="Inter ExtraBold"/>
+                <a:ea typeface="Inter ExtraBold"/>
+                <a:cs typeface="Inter ExtraBold"/>
+                <a:sym typeface="Inter ExtraBold"/>
               </a:rPr>
               <a:t>Modèle 1 : LogReg Complète (Seuil standard 0,50)</a:t>
             </a:r>
-            <a:endParaRPr b="1" sz="1800">
+            <a:endParaRPr b="0" sz="1900">
               <a:solidFill>
                 <a:srgbClr val="1D4ED8"/>
               </a:solidFill>
-              <a:latin typeface="Calibri"/>
-              <a:ea typeface="Calibri"/>
-              <a:cs typeface="Calibri"/>
-              <a:sym typeface="Calibri"/>
+              <a:latin typeface="Inter ExtraBold"/>
+              <a:ea typeface="Inter ExtraBold"/>
+              <a:cs typeface="Inter ExtraBold"/>
+              <a:sym typeface="Inter ExtraBold"/>
             </a:endParaRPr>
           </a:p>
           <a:p>
             <a:pPr indent="0" lvl="0" marL="0" rtl="0" algn="l">
               <a:spcBef>
-                <a:spcPts val="750"/>
+                <a:spcPts val="900"/>
               </a:spcBef>
               <a:spcAft>
                 <a:spcPts val="0"/>
@@ -20189,88 +20204,109 @@
               <a:buNone/>
             </a:pPr>
             <a:r>
-              <a:rPr b="1" lang="en-US">
-                <a:solidFill>
-                  <a:srgbClr val="FFFFFF"/>
-                </a:solidFill>
-                <a:highlight>
-                  <a:srgbClr val="2563EB"/>
-                </a:highlight>
-                <a:latin typeface="Calibri"/>
-                <a:ea typeface="Calibri"/>
-                <a:cs typeface="Calibri"/>
-                <a:sym typeface="Calibri"/>
+              <a:rPr lang="en-US" sz="1500">
+                <a:solidFill>
+                  <a:srgbClr val="1E3A8A"/>
+                </a:solidFill>
+                <a:latin typeface="Inter"/>
+                <a:ea typeface="Inter"/>
+                <a:cs typeface="Inter"/>
+                <a:sym typeface="Inter"/>
               </a:rPr>
-              <a:t>F1-Score: 0,7675 (+6,2 pts)</a:t>
+              <a:t>• </a:t>
             </a:r>
             <a:r>
-              <a:rPr b="1" lang="en-US">
-                <a:solidFill>
-                  <a:srgbClr val="1D4ED8"/>
-                </a:solidFill>
-                <a:latin typeface="Calibri"/>
-                <a:ea typeface="Calibri"/>
-                <a:cs typeface="Calibri"/>
-                <a:sym typeface="Calibri"/>
+              <a:rPr b="0" lang="en-US" sz="1500">
+                <a:solidFill>
+                  <a:srgbClr val="00FF00"/>
+                </a:solidFill>
+                <a:latin typeface="Inter ExtraBold"/>
+                <a:ea typeface="Inter ExtraBold"/>
+                <a:cs typeface="Inter ExtraBold"/>
+                <a:sym typeface="Inter ExtraBold"/>
+              </a:rPr>
+              <a:t>F1-Score: 0,767</a:t>
+            </a:r>
+            <a:r>
+              <a:rPr lang="en-US" sz="1500">
+                <a:solidFill>
+                  <a:srgbClr val="00FF00"/>
+                </a:solidFill>
+                <a:latin typeface="Inter ExtraBold"/>
+                <a:ea typeface="Inter ExtraBold"/>
+                <a:cs typeface="Inter ExtraBold"/>
+                <a:sym typeface="Inter ExtraBold"/>
+              </a:rPr>
+              <a:t>8</a:t>
+            </a:r>
+            <a:r>
+              <a:rPr b="0" lang="en-US" sz="1500">
+                <a:solidFill>
+                  <a:srgbClr val="00FF00"/>
+                </a:solidFill>
+                <a:latin typeface="Inter ExtraBold"/>
+                <a:ea typeface="Inter ExtraBold"/>
+                <a:cs typeface="Inter ExtraBold"/>
+                <a:sym typeface="Inter ExtraBold"/>
+              </a:rPr>
+              <a:t> (+6,2 pts)</a:t>
+            </a:r>
+            <a:r>
+              <a:rPr lang="en-US" sz="1500">
+                <a:solidFill>
+                  <a:srgbClr val="00FF00"/>
+                </a:solidFill>
+                <a:latin typeface="Inter"/>
+                <a:ea typeface="Inter"/>
+                <a:cs typeface="Inter"/>
+                <a:sym typeface="Inter"/>
               </a:rPr>
               <a:t> </a:t>
             </a:r>
             <a:r>
-              <a:rPr b="1" lang="en-US">
+              <a:rPr b="0" lang="en-US" sz="1500">
                 <a:solidFill>
                   <a:srgbClr val="1E40AF"/>
                 </a:solidFill>
-                <a:highlight>
-                  <a:srgbClr val="DBEAFE"/>
-                </a:highlight>
-                <a:latin typeface="Calibri"/>
-                <a:ea typeface="Calibri"/>
-                <a:cs typeface="Calibri"/>
-                <a:sym typeface="Calibri"/>
+                <a:latin typeface="Inter SemiBold"/>
+                <a:ea typeface="Inter SemiBold"/>
+                <a:cs typeface="Inter SemiBold"/>
+                <a:sym typeface="Inter SemiBold"/>
               </a:rPr>
               <a:t>Rappel: 68,95 %</a:t>
             </a:r>
             <a:r>
-              <a:rPr b="1" lang="en-US">
-                <a:solidFill>
-                  <a:srgbClr val="1D4ED8"/>
-                </a:solidFill>
-                <a:latin typeface="Calibri"/>
-                <a:ea typeface="Calibri"/>
-                <a:cs typeface="Calibri"/>
-                <a:sym typeface="Calibri"/>
+              <a:rPr lang="en-US" sz="1500">
+                <a:latin typeface="Inter"/>
+                <a:ea typeface="Inter"/>
+                <a:cs typeface="Inter"/>
+                <a:sym typeface="Inter"/>
               </a:rPr>
               <a:t> </a:t>
             </a:r>
             <a:r>
-              <a:rPr b="1" lang="en-US">
+              <a:rPr b="0" lang="en-US" sz="1500">
                 <a:solidFill>
                   <a:srgbClr val="1E40AF"/>
                 </a:solidFill>
-                <a:highlight>
-                  <a:srgbClr val="DBEAFE"/>
-                </a:highlight>
-                <a:latin typeface="Calibri"/>
-                <a:ea typeface="Calibri"/>
-                <a:cs typeface="Calibri"/>
-                <a:sym typeface="Calibri"/>
+                <a:latin typeface="Inter SemiBold"/>
+                <a:ea typeface="Inter SemiBold"/>
+                <a:cs typeface="Inter SemiBold"/>
+                <a:sym typeface="Inter SemiBold"/>
               </a:rPr>
               <a:t>Précision: 86,53 %</a:t>
             </a:r>
-            <a:endParaRPr b="1">
-              <a:solidFill>
-                <a:srgbClr val="1D4ED8"/>
-              </a:solidFill>
-              <a:latin typeface="Calibri"/>
-              <a:ea typeface="Calibri"/>
-              <a:cs typeface="Calibri"/>
-              <a:sym typeface="Calibri"/>
+            <a:endParaRPr sz="1500">
+              <a:latin typeface="Inter"/>
+              <a:ea typeface="Inter"/>
+              <a:cs typeface="Inter"/>
+              <a:sym typeface="Inter"/>
             </a:endParaRPr>
           </a:p>
           <a:p>
             <a:pPr indent="0" lvl="0" marL="0" rtl="0" algn="l">
               <a:spcBef>
-                <a:spcPts val="900"/>
+                <a:spcPts val="1050"/>
               </a:spcBef>
               <a:spcAft>
                 <a:spcPts val="0"/>
@@ -20278,91 +20314,52 @@
               <a:buNone/>
             </a:pPr>
             <a:r>
-              <a:rPr b="0" lang="en-US" sz="1450">
+              <a:rPr lang="en-US" sz="1500">
                 <a:solidFill>
                   <a:srgbClr val="1E3A8A"/>
                 </a:solidFill>
-                <a:latin typeface="Calibri"/>
-                <a:ea typeface="Calibri"/>
-                <a:cs typeface="Calibri"/>
-                <a:sym typeface="Calibri"/>
+                <a:latin typeface="Inter"/>
+                <a:ea typeface="Inter"/>
+                <a:cs typeface="Inter"/>
+                <a:sym typeface="Inter"/>
               </a:rPr>
-              <a:t>• ROC-AUC : </a:t>
+              <a:t>• </a:t>
             </a:r>
             <a:r>
-              <a:rPr b="1" lang="en-US" sz="1450">
+              <a:rPr b="1" lang="en-US" sz="1500">
                 <a:solidFill>
                   <a:srgbClr val="1E3A8A"/>
                 </a:solidFill>
-                <a:latin typeface="Calibri"/>
-                <a:ea typeface="Calibri"/>
-                <a:cs typeface="Calibri"/>
-                <a:sym typeface="Calibri"/>
+                <a:latin typeface="Inter"/>
+                <a:ea typeface="Inter"/>
+                <a:cs typeface="Inter"/>
+                <a:sym typeface="Inter"/>
               </a:rPr>
-              <a:t>0,9869</a:t>
+              <a:t>ROC-AUC :</a:t>
             </a:r>
             <a:r>
-              <a:rPr b="0" lang="en-US" sz="1450">
+              <a:rPr lang="en-US" sz="1500">
                 <a:solidFill>
                   <a:srgbClr val="1E3A8A"/>
                 </a:solidFill>
-                <a:latin typeface="Calibri"/>
-                <a:ea typeface="Calibri"/>
-                <a:cs typeface="Calibri"/>
-                <a:sym typeface="Calibri"/>
+                <a:latin typeface="Inter"/>
+                <a:ea typeface="Inter"/>
+                <a:cs typeface="Inter"/>
+                <a:sym typeface="Inter"/>
               </a:rPr>
-              <a:t> | Accuracy : </a:t>
+              <a:t> 0,9869 </a:t>
             </a:r>
-            <a:r>
-              <a:rPr b="1" lang="en-US" sz="1450">
-                <a:solidFill>
-                  <a:srgbClr val="1E3A8A"/>
-                </a:solidFill>
-                <a:latin typeface="Calibri"/>
-                <a:ea typeface="Calibri"/>
-                <a:cs typeface="Calibri"/>
-                <a:sym typeface="Calibri"/>
-              </a:rPr>
-              <a:t>98,65 %</a:t>
-            </a:r>
-            <a:r>
-              <a:rPr b="0" lang="en-US" sz="1450">
-                <a:solidFill>
-                  <a:srgbClr val="1E3A8A"/>
-                </a:solidFill>
-                <a:latin typeface="Calibri"/>
-                <a:ea typeface="Calibri"/>
-                <a:cs typeface="Calibri"/>
-                <a:sym typeface="Calibri"/>
-              </a:rPr>
-              <a:t> </a:t>
-            </a:r>
-            <a:r>
-              <a:rPr b="0" i="1" lang="en-US" sz="1450">
-                <a:solidFill>
-                  <a:srgbClr val="D97706"/>
-                </a:solidFill>
-                <a:latin typeface="Calibri"/>
-                <a:ea typeface="Calibri"/>
-                <a:cs typeface="Calibri"/>
-                <a:sym typeface="Calibri"/>
-              </a:rPr>
-              <a:t>(Trompeuse)</a:t>
-            </a:r>
-            <a:endParaRPr b="0" sz="1450">
-              <a:solidFill>
-                <a:srgbClr val="1E3A8A"/>
-              </a:solidFill>
-              <a:latin typeface="Calibri"/>
-              <a:ea typeface="Calibri"/>
-              <a:cs typeface="Calibri"/>
-              <a:sym typeface="Calibri"/>
+            <a:endParaRPr sz="1500">
+              <a:latin typeface="Inter"/>
+              <a:ea typeface="Inter"/>
+              <a:cs typeface="Inter"/>
+              <a:sym typeface="Inter"/>
             </a:endParaRPr>
           </a:p>
           <a:p>
             <a:pPr indent="0" lvl="0" marL="0" rtl="0" algn="l">
               <a:spcBef>
-                <a:spcPts val="450"/>
+                <a:spcPts val="750"/>
               </a:spcBef>
               <a:spcAft>
                 <a:spcPts val="0"/>
@@ -20370,25 +20367,25 @@
               <a:buNone/>
             </a:pPr>
             <a:r>
-              <a:rPr b="0" lang="en-US" sz="1450">
+              <a:rPr lang="en-US" sz="1500">
                 <a:solidFill>
                   <a:srgbClr val="1E3A8A"/>
                 </a:solidFill>
-                <a:latin typeface="Calibri"/>
-                <a:ea typeface="Calibri"/>
-                <a:cs typeface="Calibri"/>
-                <a:sym typeface="Calibri"/>
+                <a:latin typeface="Inter"/>
+                <a:ea typeface="Inter"/>
+                <a:cs typeface="Inter"/>
+                <a:sym typeface="Inter"/>
               </a:rPr>
               <a:t>• L'intégration du pays, de la source et du profil utilisateur améliore nettement le rappel.</a:t>
             </a:r>
-            <a:endParaRPr b="0" sz="1450">
+            <a:endParaRPr sz="1500">
               <a:solidFill>
                 <a:srgbClr val="1E3A8A"/>
               </a:solidFill>
-              <a:latin typeface="Calibri"/>
-              <a:ea typeface="Calibri"/>
-              <a:cs typeface="Calibri"/>
-              <a:sym typeface="Calibri"/>
+              <a:latin typeface="Inter"/>
+              <a:ea typeface="Inter"/>
+              <a:cs typeface="Inter"/>
+              <a:sym typeface="Inter"/>
             </a:endParaRPr>
           </a:p>
         </p:txBody>
@@ -20427,7 +20424,7 @@
         <p:spPr>
           <a:xfrm>
             <a:off x="731520" y="411480"/>
-            <a:ext cx="10698480" cy="320040"/>
+            <a:ext cx="10698600" cy="277200"/>
           </a:xfrm>
           <a:prstGeom prst="rect">
             <a:avLst/>
@@ -20461,7 +20458,7 @@
               <a:buNone/>
             </a:pPr>
             <a:r>
-              <a:rPr b="1" i="0" lang="en-US" sz="1000" u="none" cap="none" strike="noStrike">
+              <a:rPr b="1" i="0" lang="en-US" sz="1800" u="none" cap="none" strike="noStrike">
                 <a:solidFill>
                   <a:srgbClr val="2563EB"/>
                 </a:solidFill>
@@ -20472,7 +20469,7 @@
               </a:rPr>
               <a:t>ÉTAPE 05  |  OPTIMISATION MÉTIER</a:t>
             </a:r>
-            <a:endParaRPr b="0" i="0" sz="1400" u="none" cap="none" strike="noStrike">
+            <a:endParaRPr b="0" i="0" sz="2200" u="none" cap="none" strike="noStrike">
               <a:solidFill>
                 <a:srgbClr val="000000"/>
               </a:solidFill>
@@ -20558,8 +20555,8 @@
         </p:nvSpPr>
         <p:spPr>
           <a:xfrm>
-            <a:off x="731520" y="1234440"/>
-            <a:ext cx="10698480" cy="320040"/>
+            <a:off x="731457" y="1109740"/>
+            <a:ext cx="10698600" cy="323100"/>
           </a:xfrm>
           <a:prstGeom prst="rect">
             <a:avLst/>
@@ -20593,7 +20590,7 @@
               <a:buNone/>
             </a:pPr>
             <a:r>
-              <a:rPr b="0" i="0" lang="en-US" sz="1200" u="none" cap="none" strike="noStrike">
+              <a:rPr b="0" i="0" lang="en-US" sz="2100" u="none" cap="none" strike="noStrike">
                 <a:solidFill>
                   <a:srgbClr val="64748B"/>
                 </a:solidFill>
@@ -20604,7 +20601,7 @@
               </a:rPr>
               <a:t>Ajuster le seuil de décision à 0,45 pour maximiser les vraies conversions captées</a:t>
             </a:r>
-            <a:endParaRPr b="0" i="0" sz="1400" u="none" cap="none" strike="noStrike">
+            <a:endParaRPr b="0" i="0" sz="2300" u="none" cap="none" strike="noStrike">
               <a:solidFill>
                 <a:srgbClr val="000000"/>
               </a:solidFill>
@@ -20794,63 +20791,9 @@
           </a:p>
         </p:txBody>
       </p:sp>
-      <p:pic>
-        <p:nvPicPr>
-          <p:cNvPr descr="05_threshold_optimization_curve.png" id="172" name="Google Shape;172;p6"/>
-          <p:cNvPicPr preferRelativeResize="0"/>
-          <p:nvPr/>
-        </p:nvPicPr>
-        <p:blipFill rotWithShape="1">
-          <a:blip r:embed="rId3">
-            <a:alphaModFix/>
-          </a:blip>
-          <a:srcRect b="0" l="0" r="0" t="0"/>
-          <a:stretch/>
-        </p:blipFill>
-        <p:spPr>
-          <a:xfrm>
-            <a:off x="731520" y="1645920"/>
-            <a:ext cx="5486400" cy="3291840"/>
-          </a:xfrm>
-          <a:prstGeom prst="rect">
-            <a:avLst/>
-          </a:prstGeom>
-          <a:noFill/>
-          <a:ln>
-            <a:noFill/>
-          </a:ln>
-        </p:spPr>
-      </p:pic>
-      <p:pic>
-        <p:nvPicPr>
-          <p:cNvPr descr="04_confusion_matrix_logreg.png" id="173" name="Google Shape;173;p6"/>
-          <p:cNvPicPr preferRelativeResize="0"/>
-          <p:nvPr/>
-        </p:nvPicPr>
-        <p:blipFill rotWithShape="1">
-          <a:blip r:embed="rId4">
-            <a:alphaModFix/>
-          </a:blip>
-          <a:srcRect b="0" l="0" r="0" t="0"/>
-          <a:stretch/>
-        </p:blipFill>
-        <p:spPr>
-          <a:xfrm>
-            <a:off x="6492240" y="1645920"/>
-            <a:ext cx="4967935" cy="3291840"/>
-          </a:xfrm>
-          <a:prstGeom prst="rect">
-            <a:avLst/>
-          </a:prstGeom>
-          <a:noFill/>
-          <a:ln>
-            <a:noFill/>
-          </a:ln>
-        </p:spPr>
-      </p:pic>
       <p:sp>
         <p:nvSpPr>
-          <p:cNvPr id="174" name="Google Shape;174;p6"/>
+          <p:cNvPr id="172" name="Google Shape;172;p6"/>
           <p:cNvSpPr/>
           <p:nvPr/>
         </p:nvSpPr>
@@ -20924,14 +20867,14 @@
       </p:sp>
       <p:sp>
         <p:nvSpPr>
-          <p:cNvPr id="175" name="Google Shape;175;p6"/>
+          <p:cNvPr id="173" name="Google Shape;173;p6"/>
           <p:cNvSpPr txBox="1"/>
           <p:nvPr/>
         </p:nvSpPr>
         <p:spPr>
           <a:xfrm>
             <a:off x="914400" y="5166360"/>
-            <a:ext cx="10362895" cy="868680"/>
+            <a:ext cx="10362900" cy="815700"/>
           </a:xfrm>
           <a:prstGeom prst="rect">
             <a:avLst/>
@@ -20965,7 +20908,7 @@
               <a:buNone/>
             </a:pPr>
             <a:r>
-              <a:rPr b="1" i="0" lang="en-US" sz="1100" u="none" cap="none" strike="noStrike">
+              <a:rPr b="1" i="0" lang="en-US" sz="1600" u="none" cap="none" strike="noStrike">
                 <a:solidFill>
                   <a:srgbClr val="059669"/>
                 </a:solidFill>
@@ -20974,9 +20917,9 @@
                 <a:cs typeface="Calibri"/>
                 <a:sym typeface="Calibri"/>
               </a:rPr>
-              <a:t>🎯 SEUIL OPTIMAL RETENU : 0,45  —  F1-SCORE = 0,7762 (MODÈLE CHAMPION)</a:t>
+              <a:t>🎯 SEUIL OPTIMAL RETENU : 0,45  —  F1-SCORE = 0,7772 (MODÈLE CHAMPION)</a:t>
             </a:r>
-            <a:endParaRPr b="0" i="0" sz="1400" u="none" cap="none" strike="noStrike">
+            <a:endParaRPr b="0" i="0" sz="1900" u="none" cap="none" strike="noStrike">
               <a:solidFill>
                 <a:srgbClr val="000000"/>
               </a:solidFill>
@@ -21005,7 +20948,7 @@
               <a:buNone/>
             </a:pPr>
             <a:r>
-              <a:rPr b="0" i="0" lang="en-US" sz="1050" u="none" cap="none" strike="noStrike">
+              <a:rPr b="0" i="0" lang="en-US" sz="1550" u="none" cap="none" strike="noStrike">
                 <a:solidFill>
                   <a:srgbClr val="0F172A"/>
                 </a:solidFill>
@@ -21014,9 +20957,9 @@
                 <a:cs typeface="Calibri"/>
                 <a:sym typeface="Calibri"/>
               </a:rPr>
-              <a:t>• Bilan Matrice (Validation) : 1 318 Vrais Positifs (Rappel : 71,79 %) et seulement 242 Faux Positifs (Précision : 84,49 %).</a:t>
+              <a:t>• Bilan Matrice (Validation) : 1 320 Vrais Positifs (Rappel : 71,90 %) et seulement 241 Faux Positifs (Précision : 84,56 %).</a:t>
             </a:r>
-            <a:endParaRPr b="0" i="0" sz="1400" u="none" cap="none" strike="noStrike">
+            <a:endParaRPr b="0" i="0" sz="1900" u="none" cap="none" strike="noStrike">
               <a:solidFill>
                 <a:srgbClr val="000000"/>
               </a:solidFill>
@@ -21045,7 +20988,7 @@
               <a:buNone/>
             </a:pPr>
             <a:r>
-              <a:rPr b="0" i="0" lang="en-US" sz="1050" u="none" cap="none" strike="noStrike">
+              <a:rPr b="0" i="0" lang="en-US" sz="1550" u="none" cap="none" strike="noStrike">
                 <a:solidFill>
                   <a:srgbClr val="0F172A"/>
                 </a:solidFill>
@@ -21056,7 +20999,7 @@
               </a:rPr>
               <a:t>• Pourquoi le seuil plutôt que SMOTE ? Préserve des probabilités calibrées, transparentes et ajustables selon les coûts métier.</a:t>
             </a:r>
-            <a:endParaRPr b="0" i="0" sz="1400" u="none" cap="none" strike="noStrike">
+            <a:endParaRPr b="0" i="0" sz="1900" u="none" cap="none" strike="noStrike">
               <a:solidFill>
                 <a:srgbClr val="000000"/>
               </a:solidFill>
@@ -21068,6 +21011,60 @@
           </a:p>
         </p:txBody>
       </p:sp>
+      <p:pic>
+        <p:nvPicPr>
+          <p:cNvPr id="174" name="Google Shape;174;p6"/>
+          <p:cNvPicPr preferRelativeResize="0"/>
+          <p:nvPr/>
+        </p:nvPicPr>
+        <p:blipFill rotWithShape="1">
+          <a:blip r:embed="rId3">
+            <a:alphaModFix/>
+          </a:blip>
+          <a:srcRect b="0" l="0" r="0" t="0"/>
+          <a:stretch/>
+        </p:blipFill>
+        <p:spPr>
+          <a:xfrm>
+            <a:off x="968575" y="1524000"/>
+            <a:ext cx="6048126" cy="3115700"/>
+          </a:xfrm>
+          <a:prstGeom prst="rect">
+            <a:avLst/>
+          </a:prstGeom>
+          <a:noFill/>
+          <a:ln>
+            <a:noFill/>
+          </a:ln>
+        </p:spPr>
+      </p:pic>
+      <p:pic>
+        <p:nvPicPr>
+          <p:cNvPr id="175" name="Google Shape;175;p6"/>
+          <p:cNvPicPr preferRelativeResize="0"/>
+          <p:nvPr/>
+        </p:nvPicPr>
+        <p:blipFill rotWithShape="1">
+          <a:blip r:embed="rId4">
+            <a:alphaModFix/>
+          </a:blip>
+          <a:srcRect b="0" l="0" r="0" t="0"/>
+          <a:stretch/>
+        </p:blipFill>
+        <p:spPr>
+          <a:xfrm>
+            <a:off x="7451824" y="1524005"/>
+            <a:ext cx="3871893" cy="3215640"/>
+          </a:xfrm>
+          <a:prstGeom prst="rect">
+            <a:avLst/>
+          </a:prstGeom>
+          <a:noFill/>
+          <a:ln>
+            <a:noFill/>
+          </a:ln>
+        </p:spPr>
+      </p:pic>
     </p:spTree>
   </p:cSld>
   <p:clrMapOvr>
@@ -21102,7 +21099,7 @@
         <p:spPr>
           <a:xfrm>
             <a:off x="731520" y="411480"/>
-            <a:ext cx="10698480" cy="320040"/>
+            <a:ext cx="10698600" cy="261600"/>
           </a:xfrm>
           <a:prstGeom prst="rect">
             <a:avLst/>
@@ -21136,7 +21133,7 @@
               <a:buNone/>
             </a:pPr>
             <a:r>
-              <a:rPr b="1" i="0" lang="en-US" sz="1000" u="none" cap="none" strike="noStrike">
+              <a:rPr b="1" i="0" lang="en-US" sz="1700" u="none" cap="none" strike="noStrike">
                 <a:solidFill>
                   <a:srgbClr val="2563EB"/>
                 </a:solidFill>
@@ -21147,7 +21144,7 @@
               </a:rPr>
               <a:t>ÉTAPE 06  |  BENCHMARK &amp; INTERPRÉTABILITÉ</a:t>
             </a:r>
-            <a:endParaRPr b="0" i="0" sz="1400" u="none" cap="none" strike="noStrike">
+            <a:endParaRPr b="0" i="0" sz="2100" u="none" cap="none" strike="noStrike">
               <a:solidFill>
                 <a:srgbClr val="000000"/>
               </a:solidFill>
@@ -21168,7 +21165,7 @@
         <p:spPr>
           <a:xfrm>
             <a:off x="731520" y="685800"/>
-            <a:ext cx="10698480" cy="502920"/>
+            <a:ext cx="10698600" cy="338700"/>
           </a:xfrm>
           <a:prstGeom prst="rect">
             <a:avLst/>
@@ -21211,7 +21208,7 @@
                 <a:cs typeface="Calibri"/>
                 <a:sym typeface="Calibri"/>
               </a:rPr>
-              <a:t>Comparaison des Modèles &amp; Analyse des Coefficients</a:t>
+              <a:t>Comparaison des Modèles</a:t>
             </a:r>
             <a:endParaRPr b="0" i="0" sz="1400" u="none" cap="none" strike="noStrike">
               <a:solidFill>
@@ -21234,7 +21231,7 @@
         <p:spPr>
           <a:xfrm>
             <a:off x="731520" y="1234440"/>
-            <a:ext cx="10698600" cy="261600"/>
+            <a:ext cx="10698600" cy="323100"/>
           </a:xfrm>
           <a:prstGeom prst="rect">
             <a:avLst/>
@@ -21268,7 +21265,7 @@
               <a:buNone/>
             </a:pPr>
             <a:r>
-              <a:rPr b="0" i="0" lang="en-US" sz="1700" u="none" cap="none" strike="noStrike">
+              <a:rPr b="0" i="0" lang="en-US" sz="2100" u="none" cap="none" strike="noStrike">
                 <a:solidFill>
                   <a:srgbClr val="64748B"/>
                 </a:solidFill>
@@ -21279,7 +21276,7 @@
               </a:rPr>
               <a:t>La Régression Logistique surclasse les modèles non-linéaires en précision et explicabilité</a:t>
             </a:r>
-            <a:endParaRPr b="0" i="0" sz="1900" u="none" cap="none" strike="noStrike">
+            <a:endParaRPr b="0" i="0" sz="2300" u="none" cap="none" strike="noStrike">
               <a:solidFill>
                 <a:srgbClr val="000000"/>
               </a:solidFill>
@@ -21471,21 +21468,22 @@
       </p:sp>
       <p:pic>
         <p:nvPicPr>
-          <p:cNvPr descr="08_logreg_coefficients_odds_ratios.png" id="185" name="Google Shape;185;p7"/>
+          <p:cNvPr id="185" name="Google Shape;185;p7"/>
           <p:cNvPicPr preferRelativeResize="0"/>
           <p:nvPr/>
         </p:nvPicPr>
-        <p:blipFill rotWithShape="1">
+        <p:blipFill>
           <a:blip r:embed="rId3">
             <a:alphaModFix/>
           </a:blip>
-          <a:srcRect b="0" l="0" r="0" t="0"/>
-          <a:stretch/>
+          <a:stretch>
+            <a:fillRect/>
+          </a:stretch>
         </p:blipFill>
         <p:spPr>
           <a:xfrm>
-            <a:off x="720565" y="1645920"/>
-            <a:ext cx="5486400" cy="4389119"/>
+            <a:off x="1293838" y="1661475"/>
+            <a:ext cx="9604000" cy="4635400"/>
           </a:xfrm>
           <a:prstGeom prst="rect">
             <a:avLst/>
@@ -21496,1281 +21494,6 @@
           </a:ln>
         </p:spPr>
       </p:pic>
-      <p:sp>
-        <p:nvSpPr>
-          <p:cNvPr id="186" name="Google Shape;186;p7"/>
-          <p:cNvSpPr/>
-          <p:nvPr/>
-        </p:nvSpPr>
-        <p:spPr>
-          <a:xfrm>
-            <a:off x="6492240" y="1645920"/>
-            <a:ext cx="4967935" cy="4389120"/>
-          </a:xfrm>
-          <a:prstGeom prst="roundRect">
-            <a:avLst>
-              <a:gd fmla="val 16667" name="adj"/>
-            </a:avLst>
-          </a:prstGeom>
-          <a:solidFill>
-            <a:srgbClr val="FFFFFF"/>
-          </a:solidFill>
-          <a:ln cap="flat" cmpd="sng" w="12700">
-            <a:solidFill>
-              <a:srgbClr val="E2E8F0"/>
-            </a:solidFill>
-            <a:prstDash val="solid"/>
-            <a:round/>
-            <a:headEnd len="sm" w="sm" type="none"/>
-            <a:tailEnd len="sm" w="sm" type="none"/>
-          </a:ln>
-          <a:effectLst>
-            <a:outerShdw blurRad="40000" rotWithShape="0" dir="5400000" dist="23000">
-              <a:srgbClr val="000000">
-                <a:alpha val="34902"/>
-              </a:srgbClr>
-            </a:outerShdw>
-          </a:effectLst>
-        </p:spPr>
-        <p:txBody>
-          <a:bodyPr anchorCtr="0" anchor="ctr" bIns="45700" lIns="91425" spcFirstLastPara="1" rIns="91425" wrap="square" tIns="45700">
-            <a:noAutofit/>
-          </a:bodyPr>
-          <a:lstStyle/>
-          <a:p>
-            <a:pPr indent="0" lvl="0" marL="0" marR="0" rtl="0" algn="ctr">
-              <a:lnSpc>
-                <a:spcPct val="100000"/>
-              </a:lnSpc>
-              <a:spcBef>
-                <a:spcPts val="0"/>
-              </a:spcBef>
-              <a:spcAft>
-                <a:spcPts val="0"/>
-              </a:spcAft>
-              <a:buClr>
-                <a:srgbClr val="000000"/>
-              </a:buClr>
-              <a:buSzPts val="1800"/>
-              <a:buFont typeface="Arial"/>
-              <a:buNone/>
-            </a:pPr>
-            <a:r>
-              <a:t/>
-            </a:r>
-            <a:endParaRPr b="0" i="0" sz="1800" u="none" cap="none" strike="noStrike">
-              <a:solidFill>
-                <a:schemeClr val="dk1"/>
-              </a:solidFill>
-              <a:latin typeface="Calibri"/>
-              <a:ea typeface="Calibri"/>
-              <a:cs typeface="Calibri"/>
-              <a:sym typeface="Calibri"/>
-            </a:endParaRPr>
-          </a:p>
-        </p:txBody>
-      </p:sp>
-      <p:graphicFrame>
-        <p:nvGraphicFramePr>
-          <p:cNvPr id="187" name="Google Shape;187;p7"/>
-          <p:cNvGraphicFramePr/>
-          <p:nvPr/>
-        </p:nvGraphicFramePr>
-        <p:xfrm>
-          <a:off x="6675120" y="1783080"/>
-          <a:ext cx="3000000" cy="3000000"/>
-        </p:xfrm>
-        <a:graphic>
-          <a:graphicData uri="http://schemas.openxmlformats.org/drawingml/2006/table">
-            <a:tbl>
-              <a:tblPr bandRow="1" firstRow="1">
-                <a:noFill/>
-                <a:tableStyleId>{2F317BC0-B064-43F5-9045-13844AA80701}</a:tableStyleId>
-              </a:tblPr>
-              <a:tblGrid>
-                <a:gridCol w="2011675"/>
-                <a:gridCol w="822950"/>
-                <a:gridCol w="822950"/>
-                <a:gridCol w="944575"/>
-              </a:tblGrid>
-              <a:tr h="320050">
-                <a:tc>
-                  <a:txBody>
-                    <a:bodyPr/>
-                    <a:lstStyle/>
-                    <a:p>
-                      <a:pPr indent="0" lvl="0" marL="0" marR="0" rtl="0" algn="ctr">
-                        <a:lnSpc>
-                          <a:spcPct val="100000"/>
-                        </a:lnSpc>
-                        <a:spcBef>
-                          <a:spcPts val="0"/>
-                        </a:spcBef>
-                        <a:spcAft>
-                          <a:spcPts val="0"/>
-                        </a:spcAft>
-                        <a:buClr>
-                          <a:srgbClr val="000000"/>
-                        </a:buClr>
-                        <a:buSzPts val="1000"/>
-                        <a:buFont typeface="Arial"/>
-                        <a:buNone/>
-                      </a:pPr>
-                      <a:r>
-                        <a:rPr b="1" lang="en-US" sz="1000" u="none" cap="none" strike="noStrike">
-                          <a:solidFill>
-                            <a:srgbClr val="FFFFFF"/>
-                          </a:solidFill>
-                        </a:rPr>
-                        <a:t>Modèle</a:t>
-                      </a:r>
-                      <a:endParaRPr sz="1400" u="none" cap="none" strike="noStrike"/>
-                    </a:p>
-                  </a:txBody>
-                  <a:tcPr marT="45725" marB="45725" marR="91450" marL="91450">
-                    <a:solidFill>
-                      <a:srgbClr val="0F172A"/>
-                    </a:solidFill>
-                  </a:tcPr>
-                </a:tc>
-                <a:tc>
-                  <a:txBody>
-                    <a:bodyPr/>
-                    <a:lstStyle/>
-                    <a:p>
-                      <a:pPr indent="0" lvl="0" marL="0" marR="0" rtl="0" algn="ctr">
-                        <a:lnSpc>
-                          <a:spcPct val="100000"/>
-                        </a:lnSpc>
-                        <a:spcBef>
-                          <a:spcPts val="0"/>
-                        </a:spcBef>
-                        <a:spcAft>
-                          <a:spcPts val="0"/>
-                        </a:spcAft>
-                        <a:buClr>
-                          <a:srgbClr val="000000"/>
-                        </a:buClr>
-                        <a:buSzPts val="1000"/>
-                        <a:buFont typeface="Arial"/>
-                        <a:buNone/>
-                      </a:pPr>
-                      <a:r>
-                        <a:rPr b="1" lang="en-US" sz="1000" u="none" cap="none" strike="noStrike">
-                          <a:solidFill>
-                            <a:srgbClr val="FFFFFF"/>
-                          </a:solidFill>
-                        </a:rPr>
-                        <a:t>F1</a:t>
-                      </a:r>
-                      <a:endParaRPr sz="1400" u="none" cap="none" strike="noStrike"/>
-                    </a:p>
-                  </a:txBody>
-                  <a:tcPr marT="45725" marB="45725" marR="91450" marL="91450">
-                    <a:solidFill>
-                      <a:srgbClr val="0F172A"/>
-                    </a:solidFill>
-                  </a:tcPr>
-                </a:tc>
-                <a:tc>
-                  <a:txBody>
-                    <a:bodyPr/>
-                    <a:lstStyle/>
-                    <a:p>
-                      <a:pPr indent="0" lvl="0" marL="0" marR="0" rtl="0" algn="ctr">
-                        <a:lnSpc>
-                          <a:spcPct val="100000"/>
-                        </a:lnSpc>
-                        <a:spcBef>
-                          <a:spcPts val="0"/>
-                        </a:spcBef>
-                        <a:spcAft>
-                          <a:spcPts val="0"/>
-                        </a:spcAft>
-                        <a:buClr>
-                          <a:srgbClr val="000000"/>
-                        </a:buClr>
-                        <a:buSzPts val="1000"/>
-                        <a:buFont typeface="Arial"/>
-                        <a:buNone/>
-                      </a:pPr>
-                      <a:r>
-                        <a:rPr b="1" lang="en-US" sz="1000" u="none" cap="none" strike="noStrike">
-                          <a:solidFill>
-                            <a:srgbClr val="FFFFFF"/>
-                          </a:solidFill>
-                        </a:rPr>
-                        <a:t>Rappel</a:t>
-                      </a:r>
-                      <a:endParaRPr sz="1400" u="none" cap="none" strike="noStrike"/>
-                    </a:p>
-                  </a:txBody>
-                  <a:tcPr marT="45725" marB="45725" marR="91450" marL="91450">
-                    <a:solidFill>
-                      <a:srgbClr val="0F172A"/>
-                    </a:solidFill>
-                  </a:tcPr>
-                </a:tc>
-                <a:tc>
-                  <a:txBody>
-                    <a:bodyPr/>
-                    <a:lstStyle/>
-                    <a:p>
-                      <a:pPr indent="0" lvl="0" marL="0" marR="0" rtl="0" algn="ctr">
-                        <a:lnSpc>
-                          <a:spcPct val="100000"/>
-                        </a:lnSpc>
-                        <a:spcBef>
-                          <a:spcPts val="0"/>
-                        </a:spcBef>
-                        <a:spcAft>
-                          <a:spcPts val="0"/>
-                        </a:spcAft>
-                        <a:buClr>
-                          <a:srgbClr val="000000"/>
-                        </a:buClr>
-                        <a:buSzPts val="1000"/>
-                        <a:buFont typeface="Arial"/>
-                        <a:buNone/>
-                      </a:pPr>
-                      <a:r>
-                        <a:rPr b="1" lang="en-US" sz="1000" u="none" cap="none" strike="noStrike">
-                          <a:solidFill>
-                            <a:srgbClr val="FFFFFF"/>
-                          </a:solidFill>
-                        </a:rPr>
-                        <a:t>ROC-AUC</a:t>
-                      </a:r>
-                      <a:endParaRPr sz="1400" u="none" cap="none" strike="noStrike"/>
-                    </a:p>
-                  </a:txBody>
-                  <a:tcPr marT="45725" marB="45725" marR="91450" marL="91450">
-                    <a:solidFill>
-                      <a:srgbClr val="0F172A"/>
-                    </a:solidFill>
-                  </a:tcPr>
-                </a:tc>
-              </a:tr>
-              <a:tr h="320050">
-                <a:tc>
-                  <a:txBody>
-                    <a:bodyPr/>
-                    <a:lstStyle/>
-                    <a:p>
-                      <a:pPr indent="0" lvl="0" marL="0" marR="0" rtl="0" algn="l">
-                        <a:lnSpc>
-                          <a:spcPct val="100000"/>
-                        </a:lnSpc>
-                        <a:spcBef>
-                          <a:spcPts val="0"/>
-                        </a:spcBef>
-                        <a:spcAft>
-                          <a:spcPts val="0"/>
-                        </a:spcAft>
-                        <a:buClr>
-                          <a:srgbClr val="000000"/>
-                        </a:buClr>
-                        <a:buSzPts val="950"/>
-                        <a:buFont typeface="Arial"/>
-                        <a:buNone/>
-                      </a:pPr>
-                      <a:r>
-                        <a:rPr lang="en-US" sz="950" u="none" cap="none" strike="noStrike">
-                          <a:solidFill>
-                            <a:srgbClr val="0F172A"/>
-                          </a:solidFill>
-                        </a:rPr>
-                        <a:t>Baseline LogReg (1 var)</a:t>
-                      </a:r>
-                      <a:endParaRPr sz="1400" u="none" cap="none" strike="noStrike"/>
-                    </a:p>
-                  </a:txBody>
-                  <a:tcPr marT="45725" marB="45725" marR="91450" marL="91450">
-                    <a:solidFill>
-                      <a:srgbClr val="F8FAFC"/>
-                    </a:solidFill>
-                  </a:tcPr>
-                </a:tc>
-                <a:tc>
-                  <a:txBody>
-                    <a:bodyPr/>
-                    <a:lstStyle/>
-                    <a:p>
-                      <a:pPr indent="0" lvl="0" marL="0" marR="0" rtl="0" algn="ctr">
-                        <a:lnSpc>
-                          <a:spcPct val="100000"/>
-                        </a:lnSpc>
-                        <a:spcBef>
-                          <a:spcPts val="0"/>
-                        </a:spcBef>
-                        <a:spcAft>
-                          <a:spcPts val="0"/>
-                        </a:spcAft>
-                        <a:buClr>
-                          <a:srgbClr val="000000"/>
-                        </a:buClr>
-                        <a:buSzPts val="950"/>
-                        <a:buFont typeface="Arial"/>
-                        <a:buNone/>
-                      </a:pPr>
-                      <a:r>
-                        <a:rPr lang="en-US" sz="950" u="none" cap="none" strike="noStrike">
-                          <a:solidFill>
-                            <a:srgbClr val="0F172A"/>
-                          </a:solidFill>
-                        </a:rPr>
-                        <a:t>0,7055</a:t>
-                      </a:r>
-                      <a:endParaRPr sz="1400" u="none" cap="none" strike="noStrike"/>
-                    </a:p>
-                  </a:txBody>
-                  <a:tcPr marT="45725" marB="45725" marR="91450" marL="91450">
-                    <a:solidFill>
-                      <a:srgbClr val="F8FAFC"/>
-                    </a:solidFill>
-                  </a:tcPr>
-                </a:tc>
-                <a:tc>
-                  <a:txBody>
-                    <a:bodyPr/>
-                    <a:lstStyle/>
-                    <a:p>
-                      <a:pPr indent="0" lvl="0" marL="0" marR="0" rtl="0" algn="ctr">
-                        <a:lnSpc>
-                          <a:spcPct val="100000"/>
-                        </a:lnSpc>
-                        <a:spcBef>
-                          <a:spcPts val="0"/>
-                        </a:spcBef>
-                        <a:spcAft>
-                          <a:spcPts val="0"/>
-                        </a:spcAft>
-                        <a:buClr>
-                          <a:srgbClr val="000000"/>
-                        </a:buClr>
-                        <a:buSzPts val="950"/>
-                        <a:buFont typeface="Arial"/>
-                        <a:buNone/>
-                      </a:pPr>
-                      <a:r>
-                        <a:rPr lang="en-US" sz="950" u="none" cap="none" strike="noStrike">
-                          <a:solidFill>
-                            <a:srgbClr val="0F172A"/>
-                          </a:solidFill>
-                        </a:rPr>
-                        <a:t>61,06 %</a:t>
-                      </a:r>
-                      <a:endParaRPr sz="1400" u="none" cap="none" strike="noStrike"/>
-                    </a:p>
-                  </a:txBody>
-                  <a:tcPr marT="45725" marB="45725" marR="91450" marL="91450">
-                    <a:solidFill>
-                      <a:srgbClr val="F8FAFC"/>
-                    </a:solidFill>
-                  </a:tcPr>
-                </a:tc>
-                <a:tc>
-                  <a:txBody>
-                    <a:bodyPr/>
-                    <a:lstStyle/>
-                    <a:p>
-                      <a:pPr indent="0" lvl="0" marL="0" marR="0" rtl="0" algn="ctr">
-                        <a:lnSpc>
-                          <a:spcPct val="100000"/>
-                        </a:lnSpc>
-                        <a:spcBef>
-                          <a:spcPts val="0"/>
-                        </a:spcBef>
-                        <a:spcAft>
-                          <a:spcPts val="0"/>
-                        </a:spcAft>
-                        <a:buClr>
-                          <a:srgbClr val="000000"/>
-                        </a:buClr>
-                        <a:buSzPts val="950"/>
-                        <a:buFont typeface="Arial"/>
-                        <a:buNone/>
-                      </a:pPr>
-                      <a:r>
-                        <a:rPr lang="en-US" sz="950" u="none" cap="none" strike="noStrike">
-                          <a:solidFill>
-                            <a:srgbClr val="0F172A"/>
-                          </a:solidFill>
-                        </a:rPr>
-                        <a:t>0,9764</a:t>
-                      </a:r>
-                      <a:endParaRPr sz="1400" u="none" cap="none" strike="noStrike"/>
-                    </a:p>
-                  </a:txBody>
-                  <a:tcPr marT="45725" marB="45725" marR="91450" marL="91450">
-                    <a:solidFill>
-                      <a:srgbClr val="F8FAFC"/>
-                    </a:solidFill>
-                  </a:tcPr>
-                </a:tc>
-              </a:tr>
-              <a:tr h="320050">
-                <a:tc>
-                  <a:txBody>
-                    <a:bodyPr/>
-                    <a:lstStyle/>
-                    <a:p>
-                      <a:pPr indent="0" lvl="0" marL="0" marR="0" rtl="0" algn="l">
-                        <a:lnSpc>
-                          <a:spcPct val="100000"/>
-                        </a:lnSpc>
-                        <a:spcBef>
-                          <a:spcPts val="0"/>
-                        </a:spcBef>
-                        <a:spcAft>
-                          <a:spcPts val="0"/>
-                        </a:spcAft>
-                        <a:buClr>
-                          <a:srgbClr val="000000"/>
-                        </a:buClr>
-                        <a:buSzPts val="950"/>
-                        <a:buFont typeface="Arial"/>
-                        <a:buNone/>
-                      </a:pPr>
-                      <a:r>
-                        <a:rPr lang="en-US" sz="950" u="none" cap="none" strike="noStrike">
-                          <a:solidFill>
-                            <a:srgbClr val="0F172A"/>
-                          </a:solidFill>
-                        </a:rPr>
-                        <a:t>LogReg Complète (0.50)</a:t>
-                      </a:r>
-                      <a:endParaRPr sz="1400" u="none" cap="none" strike="noStrike"/>
-                    </a:p>
-                  </a:txBody>
-                  <a:tcPr marT="45725" marB="45725" marR="91450" marL="91450">
-                    <a:solidFill>
-                      <a:srgbClr val="FFFFFF"/>
-                    </a:solidFill>
-                  </a:tcPr>
-                </a:tc>
-                <a:tc>
-                  <a:txBody>
-                    <a:bodyPr/>
-                    <a:lstStyle/>
-                    <a:p>
-                      <a:pPr indent="0" lvl="0" marL="0" marR="0" rtl="0" algn="ctr">
-                        <a:lnSpc>
-                          <a:spcPct val="100000"/>
-                        </a:lnSpc>
-                        <a:spcBef>
-                          <a:spcPts val="0"/>
-                        </a:spcBef>
-                        <a:spcAft>
-                          <a:spcPts val="0"/>
-                        </a:spcAft>
-                        <a:buClr>
-                          <a:srgbClr val="000000"/>
-                        </a:buClr>
-                        <a:buSzPts val="950"/>
-                        <a:buFont typeface="Arial"/>
-                        <a:buNone/>
-                      </a:pPr>
-                      <a:r>
-                        <a:rPr lang="en-US" sz="950" u="none" cap="none" strike="noStrike">
-                          <a:solidFill>
-                            <a:srgbClr val="0F172A"/>
-                          </a:solidFill>
-                        </a:rPr>
-                        <a:t>0,7675</a:t>
-                      </a:r>
-                      <a:endParaRPr sz="1400" u="none" cap="none" strike="noStrike"/>
-                    </a:p>
-                  </a:txBody>
-                  <a:tcPr marT="45725" marB="45725" marR="91450" marL="91450">
-                    <a:solidFill>
-                      <a:srgbClr val="FFFFFF"/>
-                    </a:solidFill>
-                  </a:tcPr>
-                </a:tc>
-                <a:tc>
-                  <a:txBody>
-                    <a:bodyPr/>
-                    <a:lstStyle/>
-                    <a:p>
-                      <a:pPr indent="0" lvl="0" marL="0" marR="0" rtl="0" algn="ctr">
-                        <a:lnSpc>
-                          <a:spcPct val="100000"/>
-                        </a:lnSpc>
-                        <a:spcBef>
-                          <a:spcPts val="0"/>
-                        </a:spcBef>
-                        <a:spcAft>
-                          <a:spcPts val="0"/>
-                        </a:spcAft>
-                        <a:buClr>
-                          <a:srgbClr val="000000"/>
-                        </a:buClr>
-                        <a:buSzPts val="950"/>
-                        <a:buFont typeface="Arial"/>
-                        <a:buNone/>
-                      </a:pPr>
-                      <a:r>
-                        <a:rPr lang="en-US" sz="950" u="none" cap="none" strike="noStrike">
-                          <a:solidFill>
-                            <a:srgbClr val="0F172A"/>
-                          </a:solidFill>
-                        </a:rPr>
-                        <a:t>68,95 %</a:t>
-                      </a:r>
-                      <a:endParaRPr sz="1400" u="none" cap="none" strike="noStrike"/>
-                    </a:p>
-                  </a:txBody>
-                  <a:tcPr marT="45725" marB="45725" marR="91450" marL="91450">
-                    <a:solidFill>
-                      <a:srgbClr val="FFFFFF"/>
-                    </a:solidFill>
-                  </a:tcPr>
-                </a:tc>
-                <a:tc>
-                  <a:txBody>
-                    <a:bodyPr/>
-                    <a:lstStyle/>
-                    <a:p>
-                      <a:pPr indent="0" lvl="0" marL="0" marR="0" rtl="0" algn="ctr">
-                        <a:lnSpc>
-                          <a:spcPct val="100000"/>
-                        </a:lnSpc>
-                        <a:spcBef>
-                          <a:spcPts val="0"/>
-                        </a:spcBef>
-                        <a:spcAft>
-                          <a:spcPts val="0"/>
-                        </a:spcAft>
-                        <a:buClr>
-                          <a:srgbClr val="000000"/>
-                        </a:buClr>
-                        <a:buSzPts val="950"/>
-                        <a:buFont typeface="Arial"/>
-                        <a:buNone/>
-                      </a:pPr>
-                      <a:r>
-                        <a:rPr lang="en-US" sz="950" u="none" cap="none" strike="noStrike">
-                          <a:solidFill>
-                            <a:srgbClr val="0F172A"/>
-                          </a:solidFill>
-                        </a:rPr>
-                        <a:t>0,9869</a:t>
-                      </a:r>
-                      <a:endParaRPr sz="1400" u="none" cap="none" strike="noStrike"/>
-                    </a:p>
-                  </a:txBody>
-                  <a:tcPr marT="45725" marB="45725" marR="91450" marL="91450">
-                    <a:solidFill>
-                      <a:srgbClr val="FFFFFF"/>
-                    </a:solidFill>
-                  </a:tcPr>
-                </a:tc>
-              </a:tr>
-              <a:tr h="320050">
-                <a:tc>
-                  <a:txBody>
-                    <a:bodyPr/>
-                    <a:lstStyle/>
-                    <a:p>
-                      <a:pPr indent="0" lvl="0" marL="0" marR="0" rtl="0" algn="l">
-                        <a:lnSpc>
-                          <a:spcPct val="100000"/>
-                        </a:lnSpc>
-                        <a:spcBef>
-                          <a:spcPts val="0"/>
-                        </a:spcBef>
-                        <a:spcAft>
-                          <a:spcPts val="0"/>
-                        </a:spcAft>
-                        <a:buClr>
-                          <a:srgbClr val="000000"/>
-                        </a:buClr>
-                        <a:buSzPts val="950"/>
-                        <a:buFont typeface="Arial"/>
-                        <a:buNone/>
-                      </a:pPr>
-                      <a:r>
-                        <a:rPr b="1" lang="en-US" sz="950" u="none" cap="none" strike="noStrike">
-                          <a:solidFill>
-                            <a:srgbClr val="059669"/>
-                          </a:solidFill>
-                        </a:rPr>
-                        <a:t>LogReg Optimisée (0.45) 🏆</a:t>
-                      </a:r>
-                      <a:endParaRPr sz="1400" u="none" cap="none" strike="noStrike"/>
-                    </a:p>
-                  </a:txBody>
-                  <a:tcPr marT="45725" marB="45725" marR="91450" marL="91450">
-                    <a:solidFill>
-                      <a:srgbClr val="ECFDF5"/>
-                    </a:solidFill>
-                  </a:tcPr>
-                </a:tc>
-                <a:tc>
-                  <a:txBody>
-                    <a:bodyPr/>
-                    <a:lstStyle/>
-                    <a:p>
-                      <a:pPr indent="0" lvl="0" marL="0" marR="0" rtl="0" algn="ctr">
-                        <a:lnSpc>
-                          <a:spcPct val="100000"/>
-                        </a:lnSpc>
-                        <a:spcBef>
-                          <a:spcPts val="0"/>
-                        </a:spcBef>
-                        <a:spcAft>
-                          <a:spcPts val="0"/>
-                        </a:spcAft>
-                        <a:buClr>
-                          <a:srgbClr val="000000"/>
-                        </a:buClr>
-                        <a:buSzPts val="950"/>
-                        <a:buFont typeface="Arial"/>
-                        <a:buNone/>
-                      </a:pPr>
-                      <a:r>
-                        <a:rPr b="1" lang="en-US" sz="950" u="none" cap="none" strike="noStrike">
-                          <a:solidFill>
-                            <a:srgbClr val="059669"/>
-                          </a:solidFill>
-                        </a:rPr>
-                        <a:t>0,7762</a:t>
-                      </a:r>
-                      <a:endParaRPr sz="1400" u="none" cap="none" strike="noStrike"/>
-                    </a:p>
-                  </a:txBody>
-                  <a:tcPr marT="45725" marB="45725" marR="91450" marL="91450">
-                    <a:solidFill>
-                      <a:srgbClr val="ECFDF5"/>
-                    </a:solidFill>
-                  </a:tcPr>
-                </a:tc>
-                <a:tc>
-                  <a:txBody>
-                    <a:bodyPr/>
-                    <a:lstStyle/>
-                    <a:p>
-                      <a:pPr indent="0" lvl="0" marL="0" marR="0" rtl="0" algn="ctr">
-                        <a:lnSpc>
-                          <a:spcPct val="100000"/>
-                        </a:lnSpc>
-                        <a:spcBef>
-                          <a:spcPts val="0"/>
-                        </a:spcBef>
-                        <a:spcAft>
-                          <a:spcPts val="0"/>
-                        </a:spcAft>
-                        <a:buClr>
-                          <a:srgbClr val="000000"/>
-                        </a:buClr>
-                        <a:buSzPts val="950"/>
-                        <a:buFont typeface="Arial"/>
-                        <a:buNone/>
-                      </a:pPr>
-                      <a:r>
-                        <a:rPr b="1" lang="en-US" sz="950" u="none" cap="none" strike="noStrike">
-                          <a:solidFill>
-                            <a:srgbClr val="059669"/>
-                          </a:solidFill>
-                        </a:rPr>
-                        <a:t>71,79 %</a:t>
-                      </a:r>
-                      <a:endParaRPr sz="1400" u="none" cap="none" strike="noStrike"/>
-                    </a:p>
-                  </a:txBody>
-                  <a:tcPr marT="45725" marB="45725" marR="91450" marL="91450">
-                    <a:solidFill>
-                      <a:srgbClr val="ECFDF5"/>
-                    </a:solidFill>
-                  </a:tcPr>
-                </a:tc>
-                <a:tc>
-                  <a:txBody>
-                    <a:bodyPr/>
-                    <a:lstStyle/>
-                    <a:p>
-                      <a:pPr indent="0" lvl="0" marL="0" marR="0" rtl="0" algn="ctr">
-                        <a:lnSpc>
-                          <a:spcPct val="100000"/>
-                        </a:lnSpc>
-                        <a:spcBef>
-                          <a:spcPts val="0"/>
-                        </a:spcBef>
-                        <a:spcAft>
-                          <a:spcPts val="0"/>
-                        </a:spcAft>
-                        <a:buClr>
-                          <a:srgbClr val="000000"/>
-                        </a:buClr>
-                        <a:buSzPts val="950"/>
-                        <a:buFont typeface="Arial"/>
-                        <a:buNone/>
-                      </a:pPr>
-                      <a:r>
-                        <a:rPr b="1" lang="en-US" sz="950" u="none" cap="none" strike="noStrike">
-                          <a:solidFill>
-                            <a:srgbClr val="059669"/>
-                          </a:solidFill>
-                        </a:rPr>
-                        <a:t>0,9869</a:t>
-                      </a:r>
-                      <a:endParaRPr sz="1400" u="none" cap="none" strike="noStrike"/>
-                    </a:p>
-                  </a:txBody>
-                  <a:tcPr marT="45725" marB="45725" marR="91450" marL="91450">
-                    <a:solidFill>
-                      <a:srgbClr val="ECFDF5"/>
-                    </a:solidFill>
-                  </a:tcPr>
-                </a:tc>
-              </a:tr>
-              <a:tr h="320050">
-                <a:tc>
-                  <a:txBody>
-                    <a:bodyPr/>
-                    <a:lstStyle/>
-                    <a:p>
-                      <a:pPr indent="0" lvl="0" marL="0" marR="0" rtl="0" algn="l">
-                        <a:lnSpc>
-                          <a:spcPct val="100000"/>
-                        </a:lnSpc>
-                        <a:spcBef>
-                          <a:spcPts val="0"/>
-                        </a:spcBef>
-                        <a:spcAft>
-                          <a:spcPts val="0"/>
-                        </a:spcAft>
-                        <a:buClr>
-                          <a:srgbClr val="000000"/>
-                        </a:buClr>
-                        <a:buSzPts val="950"/>
-                        <a:buFont typeface="Arial"/>
-                        <a:buNone/>
-                      </a:pPr>
-                      <a:r>
-                        <a:rPr lang="en-US" sz="950" u="none" cap="none" strike="noStrike">
-                          <a:solidFill>
-                            <a:srgbClr val="0F172A"/>
-                          </a:solidFill>
-                        </a:rPr>
-                        <a:t>Random Forest (Tuned)</a:t>
-                      </a:r>
-                      <a:endParaRPr sz="1400" u="none" cap="none" strike="noStrike"/>
-                    </a:p>
-                  </a:txBody>
-                  <a:tcPr marT="45725" marB="45725" marR="91450" marL="91450">
-                    <a:solidFill>
-                      <a:srgbClr val="FFFFFF"/>
-                    </a:solidFill>
-                  </a:tcPr>
-                </a:tc>
-                <a:tc>
-                  <a:txBody>
-                    <a:bodyPr/>
-                    <a:lstStyle/>
-                    <a:p>
-                      <a:pPr indent="0" lvl="0" marL="0" marR="0" rtl="0" algn="ctr">
-                        <a:lnSpc>
-                          <a:spcPct val="100000"/>
-                        </a:lnSpc>
-                        <a:spcBef>
-                          <a:spcPts val="0"/>
-                        </a:spcBef>
-                        <a:spcAft>
-                          <a:spcPts val="0"/>
-                        </a:spcAft>
-                        <a:buClr>
-                          <a:srgbClr val="000000"/>
-                        </a:buClr>
-                        <a:buSzPts val="950"/>
-                        <a:buFont typeface="Arial"/>
-                        <a:buNone/>
-                      </a:pPr>
-                      <a:r>
-                        <a:rPr lang="en-US" sz="950" u="none" cap="none" strike="noStrike">
-                          <a:solidFill>
-                            <a:srgbClr val="0F172A"/>
-                          </a:solidFill>
-                        </a:rPr>
-                        <a:t>0,7611</a:t>
-                      </a:r>
-                      <a:endParaRPr sz="1400" u="none" cap="none" strike="noStrike"/>
-                    </a:p>
-                  </a:txBody>
-                  <a:tcPr marT="45725" marB="45725" marR="91450" marL="91450">
-                    <a:solidFill>
-                      <a:srgbClr val="FFFFFF"/>
-                    </a:solidFill>
-                  </a:tcPr>
-                </a:tc>
-                <a:tc>
-                  <a:txBody>
-                    <a:bodyPr/>
-                    <a:lstStyle/>
-                    <a:p>
-                      <a:pPr indent="0" lvl="0" marL="0" marR="0" rtl="0" algn="ctr">
-                        <a:lnSpc>
-                          <a:spcPct val="100000"/>
-                        </a:lnSpc>
-                        <a:spcBef>
-                          <a:spcPts val="0"/>
-                        </a:spcBef>
-                        <a:spcAft>
-                          <a:spcPts val="0"/>
-                        </a:spcAft>
-                        <a:buClr>
-                          <a:srgbClr val="000000"/>
-                        </a:buClr>
-                        <a:buSzPts val="950"/>
-                        <a:buFont typeface="Arial"/>
-                        <a:buNone/>
-                      </a:pPr>
-                      <a:r>
-                        <a:rPr lang="en-US" sz="950" u="none" cap="none" strike="noStrike">
-                          <a:solidFill>
-                            <a:srgbClr val="0F172A"/>
-                          </a:solidFill>
-                        </a:rPr>
-                        <a:t>75,49 %</a:t>
-                      </a:r>
-                      <a:endParaRPr sz="1400" u="none" cap="none" strike="noStrike"/>
-                    </a:p>
-                  </a:txBody>
-                  <a:tcPr marT="45725" marB="45725" marR="91450" marL="91450">
-                    <a:solidFill>
-                      <a:srgbClr val="FFFFFF"/>
-                    </a:solidFill>
-                  </a:tcPr>
-                </a:tc>
-                <a:tc>
-                  <a:txBody>
-                    <a:bodyPr/>
-                    <a:lstStyle/>
-                    <a:p>
-                      <a:pPr indent="0" lvl="0" marL="0" marR="0" rtl="0" algn="ctr">
-                        <a:lnSpc>
-                          <a:spcPct val="100000"/>
-                        </a:lnSpc>
-                        <a:spcBef>
-                          <a:spcPts val="0"/>
-                        </a:spcBef>
-                        <a:spcAft>
-                          <a:spcPts val="0"/>
-                        </a:spcAft>
-                        <a:buClr>
-                          <a:srgbClr val="000000"/>
-                        </a:buClr>
-                        <a:buSzPts val="950"/>
-                        <a:buFont typeface="Arial"/>
-                        <a:buNone/>
-                      </a:pPr>
-                      <a:r>
-                        <a:rPr lang="en-US" sz="950" u="none" cap="none" strike="noStrike">
-                          <a:solidFill>
-                            <a:srgbClr val="0F172A"/>
-                          </a:solidFill>
-                        </a:rPr>
-                        <a:t>0,9844</a:t>
-                      </a:r>
-                      <a:endParaRPr sz="1400" u="none" cap="none" strike="noStrike"/>
-                    </a:p>
-                  </a:txBody>
-                  <a:tcPr marT="45725" marB="45725" marR="91450" marL="91450">
-                    <a:solidFill>
-                      <a:srgbClr val="FFFFFF"/>
-                    </a:solidFill>
-                  </a:tcPr>
-                </a:tc>
-              </a:tr>
-              <a:tr h="320050">
-                <a:tc>
-                  <a:txBody>
-                    <a:bodyPr/>
-                    <a:lstStyle/>
-                    <a:p>
-                      <a:pPr indent="0" lvl="0" marL="0" marR="0" rtl="0" algn="l">
-                        <a:lnSpc>
-                          <a:spcPct val="100000"/>
-                        </a:lnSpc>
-                        <a:spcBef>
-                          <a:spcPts val="0"/>
-                        </a:spcBef>
-                        <a:spcAft>
-                          <a:spcPts val="0"/>
-                        </a:spcAft>
-                        <a:buClr>
-                          <a:srgbClr val="000000"/>
-                        </a:buClr>
-                        <a:buSzPts val="950"/>
-                        <a:buFont typeface="Arial"/>
-                        <a:buNone/>
-                      </a:pPr>
-                      <a:r>
-                        <a:rPr lang="en-US" sz="950" u="none" cap="none" strike="noStrike">
-                          <a:solidFill>
-                            <a:srgbClr val="0F172A"/>
-                          </a:solidFill>
-                        </a:rPr>
-                        <a:t>XGBoost Classifier</a:t>
-                      </a:r>
-                      <a:endParaRPr sz="1400" u="none" cap="none" strike="noStrike"/>
-                    </a:p>
-                  </a:txBody>
-                  <a:tcPr marT="45725" marB="45725" marR="91450" marL="91450">
-                    <a:solidFill>
-                      <a:srgbClr val="F8FAFC"/>
-                    </a:solidFill>
-                  </a:tcPr>
-                </a:tc>
-                <a:tc>
-                  <a:txBody>
-                    <a:bodyPr/>
-                    <a:lstStyle/>
-                    <a:p>
-                      <a:pPr indent="0" lvl="0" marL="0" marR="0" rtl="0" algn="ctr">
-                        <a:lnSpc>
-                          <a:spcPct val="100000"/>
-                        </a:lnSpc>
-                        <a:spcBef>
-                          <a:spcPts val="0"/>
-                        </a:spcBef>
-                        <a:spcAft>
-                          <a:spcPts val="0"/>
-                        </a:spcAft>
-                        <a:buClr>
-                          <a:srgbClr val="000000"/>
-                        </a:buClr>
-                        <a:buSzPts val="950"/>
-                        <a:buFont typeface="Arial"/>
-                        <a:buNone/>
-                      </a:pPr>
-                      <a:r>
-                        <a:rPr lang="en-US" sz="950" u="none" cap="none" strike="noStrike">
-                          <a:solidFill>
-                            <a:srgbClr val="0F172A"/>
-                          </a:solidFill>
-                        </a:rPr>
-                        <a:t>0,7763</a:t>
-                      </a:r>
-                      <a:endParaRPr sz="1400" u="none" cap="none" strike="noStrike"/>
-                    </a:p>
-                  </a:txBody>
-                  <a:tcPr marT="45725" marB="45725" marR="91450" marL="91450">
-                    <a:solidFill>
-                      <a:srgbClr val="F8FAFC"/>
-                    </a:solidFill>
-                  </a:tcPr>
-                </a:tc>
-                <a:tc>
-                  <a:txBody>
-                    <a:bodyPr/>
-                    <a:lstStyle/>
-                    <a:p>
-                      <a:pPr indent="0" lvl="0" marL="0" marR="0" rtl="0" algn="ctr">
-                        <a:lnSpc>
-                          <a:spcPct val="100000"/>
-                        </a:lnSpc>
-                        <a:spcBef>
-                          <a:spcPts val="0"/>
-                        </a:spcBef>
-                        <a:spcAft>
-                          <a:spcPts val="0"/>
-                        </a:spcAft>
-                        <a:buClr>
-                          <a:srgbClr val="000000"/>
-                        </a:buClr>
-                        <a:buSzPts val="950"/>
-                        <a:buFont typeface="Arial"/>
-                        <a:buNone/>
-                      </a:pPr>
-                      <a:r>
-                        <a:rPr lang="en-US" sz="950" u="none" cap="none" strike="noStrike">
-                          <a:solidFill>
-                            <a:srgbClr val="0F172A"/>
-                          </a:solidFill>
-                        </a:rPr>
-                        <a:t>73,80 %</a:t>
-                      </a:r>
-                      <a:endParaRPr sz="1400" u="none" cap="none" strike="noStrike"/>
-                    </a:p>
-                  </a:txBody>
-                  <a:tcPr marT="45725" marB="45725" marR="91450" marL="91450">
-                    <a:solidFill>
-                      <a:srgbClr val="F8FAFC"/>
-                    </a:solidFill>
-                  </a:tcPr>
-                </a:tc>
-                <a:tc>
-                  <a:txBody>
-                    <a:bodyPr/>
-                    <a:lstStyle/>
-                    <a:p>
-                      <a:pPr indent="0" lvl="0" marL="0" marR="0" rtl="0" algn="ctr">
-                        <a:lnSpc>
-                          <a:spcPct val="100000"/>
-                        </a:lnSpc>
-                        <a:spcBef>
-                          <a:spcPts val="0"/>
-                        </a:spcBef>
-                        <a:spcAft>
-                          <a:spcPts val="0"/>
-                        </a:spcAft>
-                        <a:buClr>
-                          <a:srgbClr val="000000"/>
-                        </a:buClr>
-                        <a:buSzPts val="950"/>
-                        <a:buFont typeface="Arial"/>
-                        <a:buNone/>
-                      </a:pPr>
-                      <a:r>
-                        <a:rPr lang="en-US" sz="950" u="none" cap="none" strike="noStrike">
-                          <a:solidFill>
-                            <a:srgbClr val="0F172A"/>
-                          </a:solidFill>
-                        </a:rPr>
-                        <a:t>0,9858</a:t>
-                      </a:r>
-                      <a:endParaRPr sz="1400" u="none" cap="none" strike="noStrike"/>
-                    </a:p>
-                  </a:txBody>
-                  <a:tcPr marT="45725" marB="45725" marR="91450" marL="91450">
-                    <a:solidFill>
-                      <a:srgbClr val="F8FAFC"/>
-                    </a:solidFill>
-                  </a:tcPr>
-                </a:tc>
-              </a:tr>
-            </a:tbl>
-          </a:graphicData>
-        </a:graphic>
-      </p:graphicFrame>
-      <p:sp>
-        <p:nvSpPr>
-          <p:cNvPr id="188" name="Google Shape;188;p7"/>
-          <p:cNvSpPr txBox="1"/>
-          <p:nvPr/>
-        </p:nvSpPr>
-        <p:spPr>
-          <a:xfrm>
-            <a:off x="6675120" y="3840480"/>
-            <a:ext cx="4602300" cy="2047200"/>
-          </a:xfrm>
-          <a:prstGeom prst="rect">
-            <a:avLst/>
-          </a:prstGeom>
-          <a:noFill/>
-          <a:ln>
-            <a:noFill/>
-          </a:ln>
-        </p:spPr>
-        <p:txBody>
-          <a:bodyPr anchorCtr="0" anchor="t" bIns="45700" lIns="91425" spcFirstLastPara="1" rIns="91425" wrap="square" tIns="45700">
-            <a:spAutoFit/>
-          </a:bodyPr>
-          <a:lstStyle/>
-          <a:p>
-            <a:pPr indent="0" lvl="0" marL="0" marR="0" rtl="0" algn="l">
-              <a:lnSpc>
-                <a:spcPct val="100000"/>
-              </a:lnSpc>
-              <a:spcBef>
-                <a:spcPts val="0"/>
-              </a:spcBef>
-              <a:spcAft>
-                <a:spcPts val="0"/>
-              </a:spcAft>
-              <a:buClr>
-                <a:srgbClr val="000000"/>
-              </a:buClr>
-              <a:buSzPts val="1150"/>
-              <a:buFont typeface="Arial"/>
-              <a:buNone/>
-            </a:pPr>
-            <a:r>
-              <a:rPr b="1" i="0" lang="en-US" sz="1350" u="none" cap="none" strike="noStrike">
-                <a:solidFill>
-                  <a:srgbClr val="0F172A"/>
-                </a:solidFill>
-                <a:latin typeface="Calibri"/>
-                <a:ea typeface="Calibri"/>
-                <a:cs typeface="Calibri"/>
-                <a:sym typeface="Calibri"/>
-              </a:rPr>
-              <a:t>💡 Lecture des Odds Ratios :</a:t>
-            </a:r>
-            <a:endParaRPr b="0" i="0" sz="1600" u="none" cap="none" strike="noStrike">
-              <a:solidFill>
-                <a:srgbClr val="000000"/>
-              </a:solidFill>
-              <a:latin typeface="Arial"/>
-              <a:ea typeface="Arial"/>
-              <a:cs typeface="Arial"/>
-              <a:sym typeface="Arial"/>
-            </a:endParaRPr>
-          </a:p>
-          <a:p>
-            <a:pPr indent="0" lvl="0" marL="0" marR="0" rtl="0" algn="l">
-              <a:lnSpc>
-                <a:spcPct val="100000"/>
-              </a:lnSpc>
-              <a:spcBef>
-                <a:spcPts val="300"/>
-              </a:spcBef>
-              <a:spcAft>
-                <a:spcPts val="0"/>
-              </a:spcAft>
-              <a:buClr>
-                <a:srgbClr val="000000"/>
-              </a:buClr>
-              <a:buSzPts val="950"/>
-              <a:buFont typeface="Arial"/>
-              <a:buNone/>
-            </a:pPr>
-            <a:r>
-              <a:rPr b="0" i="0" lang="en-US" sz="1150" u="none" cap="none" strike="noStrike">
-                <a:solidFill>
-                  <a:srgbClr val="334155"/>
-                </a:solidFill>
-                <a:latin typeface="Calibri"/>
-                <a:ea typeface="Calibri"/>
-                <a:cs typeface="Calibri"/>
-                <a:sym typeface="Calibri"/>
-              </a:rPr>
-              <a:t>• Pays (Réf: Chine) : Allemagne OR = 35,4  |  UK OR = 29,9  |  US OR = 21,3. Résider en Allemagne multiplie par 35 la cote de conversion vs Chine.</a:t>
-            </a:r>
-            <a:endParaRPr b="0" i="0" sz="1600" u="none" cap="none" strike="noStrike">
-              <a:solidFill>
-                <a:srgbClr val="000000"/>
-              </a:solidFill>
-              <a:latin typeface="Arial"/>
-              <a:ea typeface="Arial"/>
-              <a:cs typeface="Arial"/>
-              <a:sym typeface="Arial"/>
-            </a:endParaRPr>
-          </a:p>
-          <a:p>
-            <a:pPr indent="0" lvl="0" marL="0" marR="0" rtl="0" algn="l">
-              <a:lnSpc>
-                <a:spcPct val="100000"/>
-              </a:lnSpc>
-              <a:spcBef>
-                <a:spcPts val="300"/>
-              </a:spcBef>
-              <a:spcAft>
-                <a:spcPts val="0"/>
-              </a:spcAft>
-              <a:buClr>
-                <a:srgbClr val="000000"/>
-              </a:buClr>
-              <a:buSzPts val="950"/>
-              <a:buFont typeface="Arial"/>
-              <a:buNone/>
-            </a:pPr>
-            <a:r>
-              <a:rPr b="0" i="0" lang="en-US" sz="1150" u="none" cap="none" strike="noStrike">
-                <a:solidFill>
-                  <a:srgbClr val="334155"/>
-                </a:solidFill>
-                <a:latin typeface="Calibri"/>
-                <a:ea typeface="Calibri"/>
-                <a:cs typeface="Calibri"/>
-                <a:sym typeface="Calibri"/>
-              </a:rPr>
-              <a:t>• Pages Vues (OR = 12,5) : Chaque augmentation de 1 écart-type (+3,3 pages) multiplie les chances de conversion par 12,5.</a:t>
-            </a:r>
-            <a:endParaRPr b="0" i="0" sz="1600" u="none" cap="none" strike="noStrike">
-              <a:solidFill>
-                <a:srgbClr val="000000"/>
-              </a:solidFill>
-              <a:latin typeface="Arial"/>
-              <a:ea typeface="Arial"/>
-              <a:cs typeface="Arial"/>
-              <a:sym typeface="Arial"/>
-            </a:endParaRPr>
-          </a:p>
-          <a:p>
-            <a:pPr indent="0" lvl="0" marL="0" marR="0" rtl="0" algn="l">
-              <a:lnSpc>
-                <a:spcPct val="100000"/>
-              </a:lnSpc>
-              <a:spcBef>
-                <a:spcPts val="300"/>
-              </a:spcBef>
-              <a:spcAft>
-                <a:spcPts val="0"/>
-              </a:spcAft>
-              <a:buClr>
-                <a:srgbClr val="000000"/>
-              </a:buClr>
-              <a:buSzPts val="950"/>
-              <a:buFont typeface="Arial"/>
-              <a:buNone/>
-            </a:pPr>
-            <a:r>
-              <a:rPr b="0" i="0" lang="en-US" sz="1150" u="none" cap="none" strike="noStrike">
-                <a:solidFill>
-                  <a:srgbClr val="334155"/>
-                </a:solidFill>
-                <a:latin typeface="Calibri"/>
-                <a:ea typeface="Calibri"/>
-                <a:cs typeface="Calibri"/>
-                <a:sym typeface="Calibri"/>
-              </a:rPr>
-              <a:t>• Nouveau Visiteur (OR = 0,46) : Divise par plus de 2 les chances d'inscription immédiate.</a:t>
-            </a:r>
-            <a:endParaRPr b="0" i="0" sz="1600" u="none" cap="none" strike="noStrike">
-              <a:solidFill>
-                <a:srgbClr val="000000"/>
-              </a:solidFill>
-              <a:latin typeface="Arial"/>
-              <a:ea typeface="Arial"/>
-              <a:cs typeface="Arial"/>
-              <a:sym typeface="Arial"/>
-            </a:endParaRPr>
-          </a:p>
-          <a:p>
-            <a:pPr indent="0" lvl="0" marL="0" marR="0" rtl="0" algn="l">
-              <a:lnSpc>
-                <a:spcPct val="100000"/>
-              </a:lnSpc>
-              <a:spcBef>
-                <a:spcPts val="300"/>
-              </a:spcBef>
-              <a:spcAft>
-                <a:spcPts val="0"/>
-              </a:spcAft>
-              <a:buClr>
-                <a:srgbClr val="000000"/>
-              </a:buClr>
-              <a:buSzPts val="950"/>
-              <a:buFont typeface="Arial"/>
-              <a:buNone/>
-            </a:pPr>
-            <a:r>
-              <a:rPr b="0" i="0" lang="en-US" sz="1150" u="none" cap="none" strike="noStrike">
-                <a:solidFill>
-                  <a:srgbClr val="334155"/>
-                </a:solidFill>
-                <a:latin typeface="Calibri"/>
-                <a:ea typeface="Calibri"/>
-                <a:cs typeface="Calibri"/>
-                <a:sym typeface="Calibri"/>
-              </a:rPr>
-              <a:t>• Arbitrage LogReg vs XGBoost : XGBoost atteint un F1 équivalent (0,7763) mais constitue une boîte noire. LogReg est retenue pour son explicabilité directe.</a:t>
-            </a:r>
-            <a:endParaRPr b="0" i="0" sz="1600" u="none" cap="none" strike="noStrike">
-              <a:solidFill>
-                <a:srgbClr val="000000"/>
-              </a:solidFill>
-              <a:latin typeface="Arial"/>
-              <a:ea typeface="Arial"/>
-              <a:cs typeface="Arial"/>
-              <a:sym typeface="Arial"/>
-            </a:endParaRPr>
-          </a:p>
-        </p:txBody>
-      </p:sp>
     </p:spTree>
   </p:cSld>
   <p:clrMapOvr>
@@ -22784,7 +21507,7 @@
   <p:cSld>
     <p:spTree>
       <p:nvGrpSpPr>
-        <p:cNvPr id="192" name="Shape 192"/>
+        <p:cNvPr id="189" name="Shape 189"/>
         <p:cNvGrpSpPr/>
         <p:nvPr/>
       </p:nvGrpSpPr>
@@ -22798,14 +21521,14 @@
       </p:grpSpPr>
       <p:sp>
         <p:nvSpPr>
-          <p:cNvPr id="193" name="Google Shape;193;p8"/>
+          <p:cNvPr id="190" name="Google Shape;190;p8"/>
           <p:cNvSpPr txBox="1"/>
           <p:nvPr/>
         </p:nvSpPr>
         <p:spPr>
           <a:xfrm>
             <a:off x="731520" y="411480"/>
-            <a:ext cx="10698480" cy="320040"/>
+            <a:ext cx="10698600" cy="261600"/>
           </a:xfrm>
           <a:prstGeom prst="rect">
             <a:avLst/>
@@ -22839,7 +21562,7 @@
               <a:buNone/>
             </a:pPr>
             <a:r>
-              <a:rPr b="1" i="0" lang="en-US" sz="1000" u="none" cap="none" strike="noStrike">
+              <a:rPr b="1" i="0" lang="en-US" sz="1700" u="none" cap="none" strike="noStrike">
                 <a:solidFill>
                   <a:srgbClr val="2563EB"/>
                 </a:solidFill>
@@ -22850,7 +21573,7 @@
               </a:rPr>
               <a:t>ÉTAPE 07  |  PLAN D'ACTION &amp; CLÔTURE</a:t>
             </a:r>
-            <a:endParaRPr b="0" i="0" sz="1400" u="none" cap="none" strike="noStrike">
+            <a:endParaRPr b="0" i="0" sz="2100" u="none" cap="none" strike="noStrike">
               <a:solidFill>
                 <a:srgbClr val="000000"/>
               </a:solidFill>
@@ -22864,7 +21587,7 @@
       </p:sp>
       <p:sp>
         <p:nvSpPr>
-          <p:cNvPr id="194" name="Google Shape;194;p8"/>
+          <p:cNvPr id="191" name="Google Shape;191;p8"/>
           <p:cNvSpPr txBox="1"/>
           <p:nvPr/>
         </p:nvSpPr>
@@ -22930,7 +21653,7 @@
       </p:sp>
       <p:sp>
         <p:nvSpPr>
-          <p:cNvPr id="195" name="Google Shape;195;p8"/>
+          <p:cNvPr id="192" name="Google Shape;192;p8"/>
           <p:cNvSpPr txBox="1"/>
           <p:nvPr/>
         </p:nvSpPr>
@@ -22996,7 +21719,7 @@
       </p:sp>
       <p:sp>
         <p:nvSpPr>
-          <p:cNvPr id="196" name="Google Shape;196;p8"/>
+          <p:cNvPr id="193" name="Google Shape;193;p8"/>
           <p:cNvSpPr/>
           <p:nvPr/>
         </p:nvSpPr>
@@ -23068,7 +21791,7 @@
       </p:sp>
       <p:sp>
         <p:nvSpPr>
-          <p:cNvPr id="197" name="Google Shape;197;p8"/>
+          <p:cNvPr id="194" name="Google Shape;194;p8"/>
           <p:cNvSpPr txBox="1"/>
           <p:nvPr/>
         </p:nvSpPr>
@@ -23174,7 +21897,7 @@
       </p:sp>
       <p:sp>
         <p:nvSpPr>
-          <p:cNvPr id="198" name="Google Shape;198;p8"/>
+          <p:cNvPr id="195" name="Google Shape;195;p8"/>
           <p:cNvSpPr/>
           <p:nvPr/>
         </p:nvSpPr>
@@ -23248,7 +21971,7 @@
       </p:sp>
       <p:sp>
         <p:nvSpPr>
-          <p:cNvPr id="199" name="Google Shape;199;p8"/>
+          <p:cNvPr id="196" name="Google Shape;196;p8"/>
           <p:cNvSpPr txBox="1"/>
           <p:nvPr/>
         </p:nvSpPr>
@@ -23434,7 +22157,7 @@
       </p:sp>
       <p:sp>
         <p:nvSpPr>
-          <p:cNvPr id="200" name="Google Shape;200;p8"/>
+          <p:cNvPr id="197" name="Google Shape;197;p8"/>
           <p:cNvSpPr/>
           <p:nvPr/>
         </p:nvSpPr>
@@ -23508,7 +22231,7 @@
       </p:sp>
       <p:sp>
         <p:nvSpPr>
-          <p:cNvPr id="201" name="Google Shape;201;p8"/>
+          <p:cNvPr id="198" name="Google Shape;198;p8"/>
           <p:cNvSpPr txBox="1"/>
           <p:nvPr/>
         </p:nvSpPr>
@@ -23694,7 +22417,7 @@
       </p:sp>
       <p:sp>
         <p:nvSpPr>
-          <p:cNvPr id="202" name="Google Shape;202;p8"/>
+          <p:cNvPr id="199" name="Google Shape;199;p8"/>
           <p:cNvSpPr/>
           <p:nvPr/>
         </p:nvSpPr>
@@ -23768,7 +22491,7 @@
       </p:sp>
       <p:sp>
         <p:nvSpPr>
-          <p:cNvPr id="203" name="Google Shape;203;p8"/>
+          <p:cNvPr id="200" name="Google Shape;200;p8"/>
           <p:cNvSpPr txBox="1"/>
           <p:nvPr/>
         </p:nvSpPr>
@@ -23954,14 +22677,14 @@
       </p:sp>
       <p:sp>
         <p:nvSpPr>
-          <p:cNvPr id="204" name="Google Shape;204;p8"/>
+          <p:cNvPr id="201" name="Google Shape;201;p8"/>
           <p:cNvSpPr/>
           <p:nvPr/>
         </p:nvSpPr>
         <p:spPr>
           <a:xfrm>
-            <a:off x="731520" y="4892040"/>
-            <a:ext cx="10728655" cy="1234440"/>
+            <a:off x="731525" y="4892050"/>
+            <a:ext cx="11034900" cy="1059000"/>
           </a:xfrm>
           <a:prstGeom prst="roundRect">
             <a:avLst>
@@ -24028,14 +22751,14 @@
       </p:sp>
       <p:sp>
         <p:nvSpPr>
-          <p:cNvPr id="205" name="Google Shape;205;p8"/>
+          <p:cNvPr id="202" name="Google Shape;202;p8"/>
           <p:cNvSpPr txBox="1"/>
           <p:nvPr/>
         </p:nvSpPr>
         <p:spPr>
           <a:xfrm>
-            <a:off x="914400" y="4983480"/>
-            <a:ext cx="10362900" cy="992700"/>
+            <a:off x="914400" y="4983475"/>
+            <a:ext cx="10851900" cy="769500"/>
           </a:xfrm>
           <a:prstGeom prst="rect">
             <a:avLst/>

</xml_diff>